<commit_message>
Formas de trabajo y primeras charlas
</commit_message>
<xml_diff>
--- a/El Eterno Retorno/El-Eterno-Retorno.pptx
+++ b/El Eterno Retorno/El-Eterno-Retorno.pptx
@@ -2,21 +2,21 @@
 <file path=ppt/presentation.xml><?xml version="1.0" encoding="utf-8"?>
 <p:presentation xmlns:p="http://schemas.openxmlformats.org/presentationml/2006/main">
   <p:sldMasterIdLst>
-    <p:sldMasterId xmlns:r="http://schemas.openxmlformats.org/officeDocument/2006/relationships" id="2147483648" r:id="R490d150a1f764ad8"/>
+    <p:sldMasterId xmlns:r="http://schemas.openxmlformats.org/officeDocument/2006/relationships" id="2147483648" r:id="Re8aa14443c214660"/>
   </p:sldMasterIdLst>
   <p:notesMasterIdLst>
-    <p:notesMasterId xmlns:r="http://schemas.openxmlformats.org/officeDocument/2006/relationships" r:id="R9ee8b25b9c5c45d9"/>
+    <p:notesMasterId xmlns:r="http://schemas.openxmlformats.org/officeDocument/2006/relationships" r:id="R1739b050b23f4ca7"/>
   </p:notesMasterIdLst>
   <p:sldIdLst>
-    <p:sldId xmlns:r="http://schemas.openxmlformats.org/officeDocument/2006/relationships" id="256" r:id="R4affa9f617d844ef"/>
-    <p:sldId xmlns:r="http://schemas.openxmlformats.org/officeDocument/2006/relationships" id="257" r:id="Rda192a43509b42f1"/>
-    <p:sldId xmlns:r="http://schemas.openxmlformats.org/officeDocument/2006/relationships" id="258" r:id="Ra57084ab626542c7"/>
-    <p:sldId xmlns:r="http://schemas.openxmlformats.org/officeDocument/2006/relationships" id="259" r:id="Ra13c23d5f0144eea"/>
-    <p:sldId xmlns:r="http://schemas.openxmlformats.org/officeDocument/2006/relationships" id="260" r:id="R58783af45504455e"/>
-    <p:sldId xmlns:r="http://schemas.openxmlformats.org/officeDocument/2006/relationships" id="261" r:id="R29d289775c9443ee"/>
-    <p:sldId xmlns:r="http://schemas.openxmlformats.org/officeDocument/2006/relationships" id="262" r:id="R6aa5dc17a54045d9"/>
-    <p:sldId xmlns:r="http://schemas.openxmlformats.org/officeDocument/2006/relationships" id="263" r:id="R0dc367718a3b4cc0"/>
-    <p:sldId xmlns:r="http://schemas.openxmlformats.org/officeDocument/2006/relationships" id="264" r:id="R17e64d3831f2411a"/>
+    <p:sldId xmlns:r="http://schemas.openxmlformats.org/officeDocument/2006/relationships" id="256" r:id="R799bcf3d911d4f03"/>
+    <p:sldId xmlns:r="http://schemas.openxmlformats.org/officeDocument/2006/relationships" id="257" r:id="R1a62dc4f6fb5459e"/>
+    <p:sldId xmlns:r="http://schemas.openxmlformats.org/officeDocument/2006/relationships" id="258" r:id="R8c3d5631c95b4148"/>
+    <p:sldId xmlns:r="http://schemas.openxmlformats.org/officeDocument/2006/relationships" id="259" r:id="Rb0a15ed87cc34233"/>
+    <p:sldId xmlns:r="http://schemas.openxmlformats.org/officeDocument/2006/relationships" id="260" r:id="Rf937326cf2ca4c92"/>
+    <p:sldId xmlns:r="http://schemas.openxmlformats.org/officeDocument/2006/relationships" id="261" r:id="R20df1cd6fef34f48"/>
+    <p:sldId xmlns:r="http://schemas.openxmlformats.org/officeDocument/2006/relationships" id="262" r:id="Rb564721663e54edc"/>
+    <p:sldId xmlns:r="http://schemas.openxmlformats.org/officeDocument/2006/relationships" id="263" r:id="Rb424520c057e49df"/>
+    <p:sldId xmlns:r="http://schemas.openxmlformats.org/officeDocument/2006/relationships" id="264" r:id="R4f7b7e90936047b9"/>
   </p:sldIdLst>
   <p:sldSz cx="12192000" cy="6858000"/>
   <p:notesSz cx="6858000" cy="9144000"/>
@@ -1091,7 +1091,7 @@
   </p:cSld>
   <p:clrMap bg1="lt1" tx1="dk1" bg2="lt2" tx2="dk2" accent1="accent1" accent2="accent2" accent3="accent3" accent4="accent4" accent5="accent5" accent6="accent6" hlink="hlink" folHlink="folHlink"/>
   <p:sldLayoutIdLst>
-    <p:sldLayoutId xmlns:r="http://schemas.openxmlformats.org/officeDocument/2006/relationships" id="2147483649" r:id="R48516d58204747f5"/>
+    <p:sldLayoutId xmlns:r="http://schemas.openxmlformats.org/officeDocument/2006/relationships" id="2147483649" r:id="R8ca3e369624a4f08"/>
   </p:sldLayoutIdLst>
   <p:txStyles>
     <p:titleStyle>
@@ -1589,7 +1589,7 @@
           <p:cNvPr id="1" name="">
             <a:extLst xmlns:a="http://schemas.openxmlformats.org/drawingml/2006/main">
               <a:ext uri="{FF2B5EF4-FFF2-40B4-BE49-F238E27FC236}">
-                <a16:creationId xmlns:a16="http://schemas.microsoft.com/office/drawing/2014/main" id="{00850F93-F979-4FF8-BA67-786D03ECA48F}"/>
+                <a16:creationId xmlns:a16="http://schemas.microsoft.com/office/drawing/2014/main" id="{D6242897-9DC4-4F82-BF9F-A51D00E0C772}"/>
               </a:ext>
             </a:extLst>
           </p:cNvPr>
@@ -1622,7 +1622,7 @@
           <p:cNvPr id="2" name="">
             <a:extLst xmlns:a="http://schemas.openxmlformats.org/drawingml/2006/main">
               <a:ext uri="{FF2B5EF4-FFF2-40B4-BE49-F238E27FC236}">
-                <a16:creationId xmlns:a16="http://schemas.microsoft.com/office/drawing/2014/main" id="{88EEF9D1-1D19-4B1D-A70C-A82144DA4B4D}"/>
+                <a16:creationId xmlns:a16="http://schemas.microsoft.com/office/drawing/2014/main" id="{379691E5-A3ED-4895-8342-CD900AE99355}"/>
               </a:ext>
             </a:extLst>
           </p:cNvPr>
@@ -1655,7 +1655,7 @@
           <p:cNvPr id="3" name="">
             <a:extLst xmlns:a="http://schemas.openxmlformats.org/drawingml/2006/main">
               <a:ext uri="{FF2B5EF4-FFF2-40B4-BE49-F238E27FC236}">
-                <a16:creationId xmlns:a16="http://schemas.microsoft.com/office/drawing/2014/main" id="{FEA7F278-6E7F-4860-9ED0-5447A6D70993}"/>
+                <a16:creationId xmlns:a16="http://schemas.microsoft.com/office/drawing/2014/main" id="{0FF7AF21-59E7-4251-9B47-7EF3A6FF581B}"/>
               </a:ext>
             </a:extLst>
           </p:cNvPr>
@@ -1719,7 +1719,7 @@
           <p:cNvPr id="4" name="">
             <a:extLst xmlns:a="http://schemas.openxmlformats.org/drawingml/2006/main">
               <a:ext uri="{FF2B5EF4-FFF2-40B4-BE49-F238E27FC236}">
-                <a16:creationId xmlns:a16="http://schemas.microsoft.com/office/drawing/2014/main" id="{BCCB35A4-6932-4022-806B-544310A8CE6C}"/>
+                <a16:creationId xmlns:a16="http://schemas.microsoft.com/office/drawing/2014/main" id="{7D6D539A-F7FA-480E-9EBA-7DAF67AC9AC2}"/>
               </a:ext>
             </a:extLst>
           </p:cNvPr>
@@ -1829,7 +1829,7 @@
           <p:cNvPr id="5" name="">
             <a:extLst xmlns:a="http://schemas.openxmlformats.org/drawingml/2006/main">
               <a:ext uri="{FF2B5EF4-FFF2-40B4-BE49-F238E27FC236}">
-                <a16:creationId xmlns:a16="http://schemas.microsoft.com/office/drawing/2014/main" id="{223AB5E0-4B0D-42C4-9A81-6C5E226EC783}"/>
+                <a16:creationId xmlns:a16="http://schemas.microsoft.com/office/drawing/2014/main" id="{DDE4796A-6531-45B3-8B56-ECEBED0D5197}"/>
               </a:ext>
             </a:extLst>
           </p:cNvPr>
@@ -1893,7 +1893,7 @@
           <p:cNvPr id="6" name="">
             <a:extLst xmlns:a="http://schemas.openxmlformats.org/drawingml/2006/main">
               <a:ext uri="{FF2B5EF4-FFF2-40B4-BE49-F238E27FC236}">
-                <a16:creationId xmlns:a16="http://schemas.microsoft.com/office/drawing/2014/main" id="{097C8AE0-007B-4D86-AE81-6F11EDC421A7}"/>
+                <a16:creationId xmlns:a16="http://schemas.microsoft.com/office/drawing/2014/main" id="{E67F8AD2-6475-4B09-8848-F8CC53512D60}"/>
               </a:ext>
             </a:extLst>
           </p:cNvPr>
@@ -1926,7 +1926,7 @@
           <p:cNvPr id="7" name="">
             <a:extLst xmlns:a="http://schemas.openxmlformats.org/drawingml/2006/main">
               <a:ext uri="{FF2B5EF4-FFF2-40B4-BE49-F238E27FC236}">
-                <a16:creationId xmlns:a16="http://schemas.microsoft.com/office/drawing/2014/main" id="{FD0B0973-7C05-4725-9121-D0E95383BF57}"/>
+                <a16:creationId xmlns:a16="http://schemas.microsoft.com/office/drawing/2014/main" id="{9BA74BC5-B05A-4D92-9AEA-7CBEB607B7A1}"/>
               </a:ext>
             </a:extLst>
           </p:cNvPr>
@@ -1990,7 +1990,7 @@
           <p:cNvPr id="8" name="">
             <a:extLst xmlns:a="http://schemas.openxmlformats.org/drawingml/2006/main">
               <a:ext uri="{FF2B5EF4-FFF2-40B4-BE49-F238E27FC236}">
-                <a16:creationId xmlns:a16="http://schemas.microsoft.com/office/drawing/2014/main" id="{457BA492-986D-4312-BF11-18EAFDA8B74C}"/>
+                <a16:creationId xmlns:a16="http://schemas.microsoft.com/office/drawing/2014/main" id="{BF7B94A9-CF49-453F-8165-68770AB74D84}"/>
               </a:ext>
             </a:extLst>
           </p:cNvPr>
@@ -2054,7 +2054,7 @@
           <p:cNvPr id="9" name="">
             <a:extLst xmlns:a="http://schemas.openxmlformats.org/drawingml/2006/main">
               <a:ext uri="{FF2B5EF4-FFF2-40B4-BE49-F238E27FC236}">
-                <a16:creationId xmlns:a16="http://schemas.microsoft.com/office/drawing/2014/main" id="{1AC18177-E3DB-4995-AD0F-C30ED462461F}"/>
+                <a16:creationId xmlns:a16="http://schemas.microsoft.com/office/drawing/2014/main" id="{6BE1571A-D140-460B-AE0E-F2C98C8F3BF7}"/>
               </a:ext>
             </a:extLst>
           </p:cNvPr>
@@ -2118,7 +2118,7 @@
           <p:cNvPr id="10" name="">
             <a:extLst xmlns:a="http://schemas.openxmlformats.org/drawingml/2006/main">
               <a:ext uri="{FF2B5EF4-FFF2-40B4-BE49-F238E27FC236}">
-                <a16:creationId xmlns:a16="http://schemas.microsoft.com/office/drawing/2014/main" id="{7075ACF9-6870-4AAB-BD25-B459AB7B84A6}"/>
+                <a16:creationId xmlns:a16="http://schemas.microsoft.com/office/drawing/2014/main" id="{E38E491B-1035-4DE5-965B-C4C1EE9CDA55}"/>
               </a:ext>
             </a:extLst>
           </p:cNvPr>
@@ -2182,7 +2182,7 @@
           <p:cNvPr id="11" name="">
             <a:extLst xmlns:a="http://schemas.openxmlformats.org/drawingml/2006/main">
               <a:ext uri="{FF2B5EF4-FFF2-40B4-BE49-F238E27FC236}">
-                <a16:creationId xmlns:a16="http://schemas.microsoft.com/office/drawing/2014/main" id="{A96EFAF0-AE35-4413-B0AF-EF3BF2B2565A}"/>
+                <a16:creationId xmlns:a16="http://schemas.microsoft.com/office/drawing/2014/main" id="{6A25898E-DF0A-4641-9B03-F31AEFCE0FED}"/>
               </a:ext>
             </a:extLst>
           </p:cNvPr>
@@ -2246,7 +2246,7 @@
           <p:cNvPr id="12" name="">
             <a:extLst xmlns:a="http://schemas.openxmlformats.org/drawingml/2006/main">
               <a:ext uri="{FF2B5EF4-FFF2-40B4-BE49-F238E27FC236}">
-                <a16:creationId xmlns:a16="http://schemas.microsoft.com/office/drawing/2014/main" id="{C1171C51-CE9E-44D3-9683-88D2502840B2}"/>
+                <a16:creationId xmlns:a16="http://schemas.microsoft.com/office/drawing/2014/main" id="{6C41D989-796E-4099-AF4F-B12847DED10B}"/>
               </a:ext>
             </a:extLst>
           </p:cNvPr>
@@ -2310,7 +2310,7 @@
           <p:cNvPr id="13" name="">
             <a:extLst xmlns:a="http://schemas.openxmlformats.org/drawingml/2006/main">
               <a:ext uri="{FF2B5EF4-FFF2-40B4-BE49-F238E27FC236}">
-                <a16:creationId xmlns:a16="http://schemas.microsoft.com/office/drawing/2014/main" id="{3FA8B513-308B-4D5B-9EAA-536637BE1A9C}"/>
+                <a16:creationId xmlns:a16="http://schemas.microsoft.com/office/drawing/2014/main" id="{895555BB-7995-439F-828F-1B19FE2F8820}"/>
               </a:ext>
             </a:extLst>
           </p:cNvPr>
@@ -2374,7 +2374,7 @@
           <p:cNvPr id="14" name="">
             <a:extLst xmlns:a="http://schemas.openxmlformats.org/drawingml/2006/main">
               <a:ext uri="{FF2B5EF4-FFF2-40B4-BE49-F238E27FC236}">
-                <a16:creationId xmlns:a16="http://schemas.microsoft.com/office/drawing/2014/main" id="{0EA195C9-A48F-40CB-B77B-DFEEE29ED20D}"/>
+                <a16:creationId xmlns:a16="http://schemas.microsoft.com/office/drawing/2014/main" id="{0D5C1067-BD50-4E7A-A723-254C189BF9E6}"/>
               </a:ext>
             </a:extLst>
           </p:cNvPr>
@@ -2438,7 +2438,7 @@
           <p:cNvPr id="15" name="">
             <a:extLst xmlns:a="http://schemas.openxmlformats.org/drawingml/2006/main">
               <a:ext uri="{FF2B5EF4-FFF2-40B4-BE49-F238E27FC236}">
-                <a16:creationId xmlns:a16="http://schemas.microsoft.com/office/drawing/2014/main" id="{76D63935-D6DB-4F1F-94E4-77833C8B3702}"/>
+                <a16:creationId xmlns:a16="http://schemas.microsoft.com/office/drawing/2014/main" id="{EE0F0EB8-AF68-498B-8CFE-BB977B3AE8E5}"/>
               </a:ext>
             </a:extLst>
           </p:cNvPr>
@@ -2471,7 +2471,7 @@
           <p:cNvPr id="16" name="">
             <a:extLst xmlns:a="http://schemas.openxmlformats.org/drawingml/2006/main">
               <a:ext uri="{FF2B5EF4-FFF2-40B4-BE49-F238E27FC236}">
-                <a16:creationId xmlns:a16="http://schemas.microsoft.com/office/drawing/2014/main" id="{F32294A5-A925-4713-BECA-AAFC78399B87}"/>
+                <a16:creationId xmlns:a16="http://schemas.microsoft.com/office/drawing/2014/main" id="{4AE314F5-4CA7-4111-A7C1-9A58F1DDD5A8}"/>
               </a:ext>
             </a:extLst>
           </p:cNvPr>
@@ -2535,7 +2535,7 @@
           <p:cNvPr id="17" name="">
             <a:extLst xmlns:a="http://schemas.openxmlformats.org/drawingml/2006/main">
               <a:ext uri="{FF2B5EF4-FFF2-40B4-BE49-F238E27FC236}">
-                <a16:creationId xmlns:a16="http://schemas.microsoft.com/office/drawing/2014/main" id="{CA08FE3D-D81E-4505-AD83-F83953C4E377}"/>
+                <a16:creationId xmlns:a16="http://schemas.microsoft.com/office/drawing/2014/main" id="{340FE2E7-84E8-425D-A414-3F9440B6CA7D}"/>
               </a:ext>
             </a:extLst>
           </p:cNvPr>
@@ -2599,7 +2599,7 @@
           <p:cNvPr id="18" name="">
             <a:extLst xmlns:a="http://schemas.openxmlformats.org/drawingml/2006/main">
               <a:ext uri="{FF2B5EF4-FFF2-40B4-BE49-F238E27FC236}">
-                <a16:creationId xmlns:a16="http://schemas.microsoft.com/office/drawing/2014/main" id="{06FA3FEC-51BD-4700-AFDD-F10A91A23BD0}"/>
+                <a16:creationId xmlns:a16="http://schemas.microsoft.com/office/drawing/2014/main" id="{105625A6-A3A5-4931-98CA-07D28ABCC70F}"/>
               </a:ext>
             </a:extLst>
           </p:cNvPr>
@@ -2632,7 +2632,7 @@
           <p:cNvPr id="19" name="">
             <a:extLst xmlns:a="http://schemas.openxmlformats.org/drawingml/2006/main">
               <a:ext uri="{FF2B5EF4-FFF2-40B4-BE49-F238E27FC236}">
-                <a16:creationId xmlns:a16="http://schemas.microsoft.com/office/drawing/2014/main" id="{D46B5FC7-9952-4627-BCD8-58740C6EBD92}"/>
+                <a16:creationId xmlns:a16="http://schemas.microsoft.com/office/drawing/2014/main" id="{8377696A-FE9D-47C6-9B20-BAB10C6FA04A}"/>
               </a:ext>
             </a:extLst>
           </p:cNvPr>
@@ -2696,7 +2696,7 @@
           <p:cNvPr id="20" name="">
             <a:extLst xmlns:a="http://schemas.openxmlformats.org/drawingml/2006/main">
               <a:ext uri="{FF2B5EF4-FFF2-40B4-BE49-F238E27FC236}">
-                <a16:creationId xmlns:a16="http://schemas.microsoft.com/office/drawing/2014/main" id="{C41AF420-AB50-491E-BA44-A9C1E1E9A1F0}"/>
+                <a16:creationId xmlns:a16="http://schemas.microsoft.com/office/drawing/2014/main" id="{3224AD39-D9F1-4371-A2D0-253DB8178E47}"/>
               </a:ext>
             </a:extLst>
           </p:cNvPr>
@@ -2760,7 +2760,7 @@
           <p:cNvPr id="21" name="">
             <a:extLst xmlns:a="http://schemas.openxmlformats.org/drawingml/2006/main">
               <a:ext uri="{FF2B5EF4-FFF2-40B4-BE49-F238E27FC236}">
-                <a16:creationId xmlns:a16="http://schemas.microsoft.com/office/drawing/2014/main" id="{26248FF2-C270-482E-B753-D7467EF67895}"/>
+                <a16:creationId xmlns:a16="http://schemas.microsoft.com/office/drawing/2014/main" id="{C5ADDC54-0A2B-41B3-A1FF-78C7642369E5}"/>
               </a:ext>
             </a:extLst>
           </p:cNvPr>
@@ -2793,7 +2793,7 @@
           <p:cNvPr id="22" name="">
             <a:extLst xmlns:a="http://schemas.openxmlformats.org/drawingml/2006/main">
               <a:ext uri="{FF2B5EF4-FFF2-40B4-BE49-F238E27FC236}">
-                <a16:creationId xmlns:a16="http://schemas.microsoft.com/office/drawing/2014/main" id="{B0820DA7-A9BA-4F7B-92B4-B5FB65B34173}"/>
+                <a16:creationId xmlns:a16="http://schemas.microsoft.com/office/drawing/2014/main" id="{E38E6D87-41BD-470C-B2A9-6AAEA856BB46}"/>
               </a:ext>
             </a:extLst>
           </p:cNvPr>
@@ -2857,7 +2857,7 @@
           <p:cNvPr id="23" name="">
             <a:extLst xmlns:a="http://schemas.openxmlformats.org/drawingml/2006/main">
               <a:ext uri="{FF2B5EF4-FFF2-40B4-BE49-F238E27FC236}">
-                <a16:creationId xmlns:a16="http://schemas.microsoft.com/office/drawing/2014/main" id="{91774877-715D-4F85-8294-0ABE1630D454}"/>
+                <a16:creationId xmlns:a16="http://schemas.microsoft.com/office/drawing/2014/main" id="{9C28DBE7-B8FB-4DD8-B256-D685046DD966}"/>
               </a:ext>
             </a:extLst>
           </p:cNvPr>
@@ -2921,7 +2921,7 @@
           <p:cNvPr id="24" name="">
             <a:extLst xmlns:a="http://schemas.openxmlformats.org/drawingml/2006/main">
               <a:ext uri="{FF2B5EF4-FFF2-40B4-BE49-F238E27FC236}">
-                <a16:creationId xmlns:a16="http://schemas.microsoft.com/office/drawing/2014/main" id="{2AAE23B4-F904-418E-890B-1B2BC3186C1B}"/>
+                <a16:creationId xmlns:a16="http://schemas.microsoft.com/office/drawing/2014/main" id="{97A59B02-9A6D-4D10-84E3-2BAB0FDF8432}"/>
               </a:ext>
             </a:extLst>
           </p:cNvPr>
@@ -2954,7 +2954,7 @@
           <p:cNvPr id="25" name="">
             <a:extLst xmlns:a="http://schemas.openxmlformats.org/drawingml/2006/main">
               <a:ext uri="{FF2B5EF4-FFF2-40B4-BE49-F238E27FC236}">
-                <a16:creationId xmlns:a16="http://schemas.microsoft.com/office/drawing/2014/main" id="{B280D4B4-4286-4E9E-906A-DC31FAD61E04}"/>
+                <a16:creationId xmlns:a16="http://schemas.microsoft.com/office/drawing/2014/main" id="{BA76B028-1913-4D42-B347-89B4CE8AC154}"/>
               </a:ext>
             </a:extLst>
           </p:cNvPr>
@@ -3018,7 +3018,7 @@
           <p:cNvPr id="26" name="">
             <a:extLst xmlns:a="http://schemas.openxmlformats.org/drawingml/2006/main">
               <a:ext uri="{FF2B5EF4-FFF2-40B4-BE49-F238E27FC236}">
-                <a16:creationId xmlns:a16="http://schemas.microsoft.com/office/drawing/2014/main" id="{D3D8544C-1428-4226-83E2-4DC1B2CFE4FB}"/>
+                <a16:creationId xmlns:a16="http://schemas.microsoft.com/office/drawing/2014/main" id="{6840AE79-72FE-46F1-A808-4A07495B55DF}"/>
               </a:ext>
             </a:extLst>
           </p:cNvPr>
@@ -3082,7 +3082,7 @@
           <p:cNvPr id="27" name="">
             <a:extLst xmlns:a="http://schemas.openxmlformats.org/drawingml/2006/main">
               <a:ext uri="{FF2B5EF4-FFF2-40B4-BE49-F238E27FC236}">
-                <a16:creationId xmlns:a16="http://schemas.microsoft.com/office/drawing/2014/main" id="{538BAD40-7D5E-46B4-8321-F9FE58D4C895}"/>
+                <a16:creationId xmlns:a16="http://schemas.microsoft.com/office/drawing/2014/main" id="{FCB3309B-6035-43B1-9F70-603D948F815E}"/>
               </a:ext>
             </a:extLst>
           </p:cNvPr>
@@ -3146,7 +3146,7 @@
           <p:cNvPr id="28" name="">
             <a:extLst xmlns:a="http://schemas.openxmlformats.org/drawingml/2006/main">
               <a:ext uri="{FF2B5EF4-FFF2-40B4-BE49-F238E27FC236}">
-                <a16:creationId xmlns:a16="http://schemas.microsoft.com/office/drawing/2014/main" id="{AB68AE5A-BB24-4358-9DDC-7FEA9049775C}"/>
+                <a16:creationId xmlns:a16="http://schemas.microsoft.com/office/drawing/2014/main" id="{B4C56369-8345-4236-BB38-B4DF5A073942}"/>
               </a:ext>
             </a:extLst>
           </p:cNvPr>
@@ -3208,7 +3208,7 @@
     </p:spTree>
     <p:extLst>
       <p:ext uri="{BB962C8B-B14F-4D97-AF65-F5344CB8AC3E}">
-        <p14:creationId xmlns:p14="http://schemas.microsoft.com/office/powerpoint/2010/main" val="617954446"/>
+        <p14:creationId xmlns:p14="http://schemas.microsoft.com/office/powerpoint/2010/main" val="553231078"/>
       </p:ext>
     </p:extLst>
   </p:cSld>
@@ -3232,7 +3232,7 @@
           <p:cNvPr id="1" name="">
             <a:extLst xmlns:a="http://schemas.openxmlformats.org/drawingml/2006/main">
               <a:ext uri="{FF2B5EF4-FFF2-40B4-BE49-F238E27FC236}">
-                <a16:creationId xmlns:a16="http://schemas.microsoft.com/office/drawing/2014/main" id="{E1D5E27C-D31B-47B4-8745-E34BD9EF93DD}"/>
+                <a16:creationId xmlns:a16="http://schemas.microsoft.com/office/drawing/2014/main" id="{878002B8-1424-4613-BF3A-0DD45D36A723}"/>
               </a:ext>
             </a:extLst>
           </p:cNvPr>
@@ -3265,7 +3265,7 @@
           <p:cNvPr id="2" name="">
             <a:extLst xmlns:a="http://schemas.openxmlformats.org/drawingml/2006/main">
               <a:ext uri="{FF2B5EF4-FFF2-40B4-BE49-F238E27FC236}">
-                <a16:creationId xmlns:a16="http://schemas.microsoft.com/office/drawing/2014/main" id="{F08FB8F4-CD68-4365-A4B8-14BFC6A1BF53}"/>
+                <a16:creationId xmlns:a16="http://schemas.microsoft.com/office/drawing/2014/main" id="{1EAFB73E-A42C-4801-90A9-BBE574E9093A}"/>
               </a:ext>
             </a:extLst>
           </p:cNvPr>
@@ -3298,7 +3298,7 @@
           <p:cNvPr id="3" name="">
             <a:extLst xmlns:a="http://schemas.openxmlformats.org/drawingml/2006/main">
               <a:ext uri="{FF2B5EF4-FFF2-40B4-BE49-F238E27FC236}">
-                <a16:creationId xmlns:a16="http://schemas.microsoft.com/office/drawing/2014/main" id="{2AE4D256-DF52-420F-81B3-3FF6BDD62D88}"/>
+                <a16:creationId xmlns:a16="http://schemas.microsoft.com/office/drawing/2014/main" id="{C7D8CF90-1687-47A6-A283-98479B712C52}"/>
               </a:ext>
             </a:extLst>
           </p:cNvPr>
@@ -3362,7 +3362,7 @@
           <p:cNvPr id="4" name="">
             <a:extLst xmlns:a="http://schemas.openxmlformats.org/drawingml/2006/main">
               <a:ext uri="{FF2B5EF4-FFF2-40B4-BE49-F238E27FC236}">
-                <a16:creationId xmlns:a16="http://schemas.microsoft.com/office/drawing/2014/main" id="{168FC318-D163-4C75-AD74-AEB208D503CD}"/>
+                <a16:creationId xmlns:a16="http://schemas.microsoft.com/office/drawing/2014/main" id="{264F179E-1112-4FC7-9353-8DC7087F7E6A}"/>
               </a:ext>
             </a:extLst>
           </p:cNvPr>
@@ -3426,7 +3426,7 @@
           <p:cNvPr id="5" name="">
             <a:extLst xmlns:a="http://schemas.openxmlformats.org/drawingml/2006/main">
               <a:ext uri="{FF2B5EF4-FFF2-40B4-BE49-F238E27FC236}">
-                <a16:creationId xmlns:a16="http://schemas.microsoft.com/office/drawing/2014/main" id="{997E895B-0F9E-4F9C-9A08-EDC1B215CAFC}"/>
+                <a16:creationId xmlns:a16="http://schemas.microsoft.com/office/drawing/2014/main" id="{8381B516-DFE3-4A4A-B110-15F6CE35BA26}"/>
               </a:ext>
             </a:extLst>
           </p:cNvPr>
@@ -3459,7 +3459,7 @@
           <p:cNvPr id="6" name="">
             <a:extLst xmlns:a="http://schemas.openxmlformats.org/drawingml/2006/main">
               <a:ext uri="{FF2B5EF4-FFF2-40B4-BE49-F238E27FC236}">
-                <a16:creationId xmlns:a16="http://schemas.microsoft.com/office/drawing/2014/main" id="{4D4341A1-B0C0-45E9-9690-7A2A28741BD0}"/>
+                <a16:creationId xmlns:a16="http://schemas.microsoft.com/office/drawing/2014/main" id="{893CF7B2-3620-48BD-8A42-C3E392BD0733}"/>
               </a:ext>
             </a:extLst>
           </p:cNvPr>
@@ -3523,7 +3523,7 @@
           <p:cNvPr id="7" name="">
             <a:extLst xmlns:a="http://schemas.openxmlformats.org/drawingml/2006/main">
               <a:ext uri="{FF2B5EF4-FFF2-40B4-BE49-F238E27FC236}">
-                <a16:creationId xmlns:a16="http://schemas.microsoft.com/office/drawing/2014/main" id="{C5DBB805-A853-40A5-A1A3-7745941DEE32}"/>
+                <a16:creationId xmlns:a16="http://schemas.microsoft.com/office/drawing/2014/main" id="{F80194DB-DAAA-4B39-8DEE-4EB75BC9CBC7}"/>
               </a:ext>
             </a:extLst>
           </p:cNvPr>
@@ -3556,7 +3556,7 @@
           <p:cNvPr id="8" name="">
             <a:extLst xmlns:a="http://schemas.openxmlformats.org/drawingml/2006/main">
               <a:ext uri="{FF2B5EF4-FFF2-40B4-BE49-F238E27FC236}">
-                <a16:creationId xmlns:a16="http://schemas.microsoft.com/office/drawing/2014/main" id="{E3767638-8C5E-4D4F-B36F-1123E2306CFB}"/>
+                <a16:creationId xmlns:a16="http://schemas.microsoft.com/office/drawing/2014/main" id="{6EE75960-BC06-4ED2-AF5F-0EC95D72E403}"/>
               </a:ext>
             </a:extLst>
           </p:cNvPr>
@@ -3620,7 +3620,7 @@
           <p:cNvPr id="9" name="">
             <a:extLst xmlns:a="http://schemas.openxmlformats.org/drawingml/2006/main">
               <a:ext uri="{FF2B5EF4-FFF2-40B4-BE49-F238E27FC236}">
-                <a16:creationId xmlns:a16="http://schemas.microsoft.com/office/drawing/2014/main" id="{E6F12519-8F07-4813-940E-4A48E65A12D0}"/>
+                <a16:creationId xmlns:a16="http://schemas.microsoft.com/office/drawing/2014/main" id="{498B26ED-84AB-468D-9793-07B5F2BA263A}"/>
               </a:ext>
             </a:extLst>
           </p:cNvPr>
@@ -3653,7 +3653,7 @@
           <p:cNvPr id="10" name="">
             <a:extLst xmlns:a="http://schemas.openxmlformats.org/drawingml/2006/main">
               <a:ext uri="{FF2B5EF4-FFF2-40B4-BE49-F238E27FC236}">
-                <a16:creationId xmlns:a16="http://schemas.microsoft.com/office/drawing/2014/main" id="{DC3D4F73-ED25-4559-B949-E1844C540350}"/>
+                <a16:creationId xmlns:a16="http://schemas.microsoft.com/office/drawing/2014/main" id="{DD9E608C-3A5C-4DF6-B2D0-01F7237F2C28}"/>
               </a:ext>
             </a:extLst>
           </p:cNvPr>
@@ -3717,7 +3717,7 @@
           <p:cNvPr id="11" name="">
             <a:extLst xmlns:a="http://schemas.openxmlformats.org/drawingml/2006/main">
               <a:ext uri="{FF2B5EF4-FFF2-40B4-BE49-F238E27FC236}">
-                <a16:creationId xmlns:a16="http://schemas.microsoft.com/office/drawing/2014/main" id="{1886039A-E735-448F-82FB-29426882B726}"/>
+                <a16:creationId xmlns:a16="http://schemas.microsoft.com/office/drawing/2014/main" id="{726A416F-308C-4A6D-A855-06A513EA5164}"/>
               </a:ext>
             </a:extLst>
           </p:cNvPr>
@@ -3750,7 +3750,7 @@
           <p:cNvPr id="12" name="">
             <a:extLst xmlns:a="http://schemas.openxmlformats.org/drawingml/2006/main">
               <a:ext uri="{FF2B5EF4-FFF2-40B4-BE49-F238E27FC236}">
-                <a16:creationId xmlns:a16="http://schemas.microsoft.com/office/drawing/2014/main" id="{8550A7E2-E21C-4E5A-ABCC-A2D26E14AFCC}"/>
+                <a16:creationId xmlns:a16="http://schemas.microsoft.com/office/drawing/2014/main" id="{17B776A6-D8D2-4620-8F34-7EFBD7ED78CD}"/>
               </a:ext>
             </a:extLst>
           </p:cNvPr>
@@ -3814,7 +3814,7 @@
           <p:cNvPr id="13" name="">
             <a:extLst xmlns:a="http://schemas.openxmlformats.org/drawingml/2006/main">
               <a:ext uri="{FF2B5EF4-FFF2-40B4-BE49-F238E27FC236}">
-                <a16:creationId xmlns:a16="http://schemas.microsoft.com/office/drawing/2014/main" id="{5FC139BF-265F-4B76-B297-344DBA6D59F8}"/>
+                <a16:creationId xmlns:a16="http://schemas.microsoft.com/office/drawing/2014/main" id="{555DEB9A-CE19-450E-B30C-318C388C848A}"/>
               </a:ext>
             </a:extLst>
           </p:cNvPr>
@@ -3847,7 +3847,7 @@
           <p:cNvPr id="14" name="">
             <a:extLst xmlns:a="http://schemas.openxmlformats.org/drawingml/2006/main">
               <a:ext uri="{FF2B5EF4-FFF2-40B4-BE49-F238E27FC236}">
-                <a16:creationId xmlns:a16="http://schemas.microsoft.com/office/drawing/2014/main" id="{A4E96103-DE78-42A3-B017-0C0A31988BB8}"/>
+                <a16:creationId xmlns:a16="http://schemas.microsoft.com/office/drawing/2014/main" id="{B7D4E77D-CB70-4F88-800F-970E84C82552}"/>
               </a:ext>
             </a:extLst>
           </p:cNvPr>
@@ -3911,7 +3911,7 @@
           <p:cNvPr id="15" name="">
             <a:extLst xmlns:a="http://schemas.openxmlformats.org/drawingml/2006/main">
               <a:ext uri="{FF2B5EF4-FFF2-40B4-BE49-F238E27FC236}">
-                <a16:creationId xmlns:a16="http://schemas.microsoft.com/office/drawing/2014/main" id="{8956E7BA-3C9D-4DF8-8ACF-CCB9C1D53108}"/>
+                <a16:creationId xmlns:a16="http://schemas.microsoft.com/office/drawing/2014/main" id="{A91D7F8D-8E50-4D92-A7CC-BA01F5BFFFC5}"/>
               </a:ext>
             </a:extLst>
           </p:cNvPr>
@@ -3944,7 +3944,7 @@
           <p:cNvPr id="16" name="">
             <a:extLst xmlns:a="http://schemas.openxmlformats.org/drawingml/2006/main">
               <a:ext uri="{FF2B5EF4-FFF2-40B4-BE49-F238E27FC236}">
-                <a16:creationId xmlns:a16="http://schemas.microsoft.com/office/drawing/2014/main" id="{310B1263-2053-4F98-84CB-B8B75E2E0F34}"/>
+                <a16:creationId xmlns:a16="http://schemas.microsoft.com/office/drawing/2014/main" id="{BF268CF9-953D-49D8-93DD-C68E125028A8}"/>
               </a:ext>
             </a:extLst>
           </p:cNvPr>
@@ -4008,7 +4008,7 @@
           <p:cNvPr id="17" name="">
             <a:extLst xmlns:a="http://schemas.openxmlformats.org/drawingml/2006/main">
               <a:ext uri="{FF2B5EF4-FFF2-40B4-BE49-F238E27FC236}">
-                <a16:creationId xmlns:a16="http://schemas.microsoft.com/office/drawing/2014/main" id="{3D095576-2610-462A-8F41-A36F88CBC04F}"/>
+                <a16:creationId xmlns:a16="http://schemas.microsoft.com/office/drawing/2014/main" id="{5151D5A4-A7B7-4684-A393-D54ED3A55A80}"/>
               </a:ext>
             </a:extLst>
           </p:cNvPr>
@@ -4041,7 +4041,7 @@
           <p:cNvPr id="18" name="">
             <a:extLst xmlns:a="http://schemas.openxmlformats.org/drawingml/2006/main">
               <a:ext uri="{FF2B5EF4-FFF2-40B4-BE49-F238E27FC236}">
-                <a16:creationId xmlns:a16="http://schemas.microsoft.com/office/drawing/2014/main" id="{12A9646C-F906-4627-A979-3958E22B276D}"/>
+                <a16:creationId xmlns:a16="http://schemas.microsoft.com/office/drawing/2014/main" id="{7A26C314-39EE-4984-A3A9-9345DD676DAD}"/>
               </a:ext>
             </a:extLst>
           </p:cNvPr>
@@ -4105,7 +4105,7 @@
           <p:cNvPr id="19" name="">
             <a:extLst xmlns:a="http://schemas.openxmlformats.org/drawingml/2006/main">
               <a:ext uri="{FF2B5EF4-FFF2-40B4-BE49-F238E27FC236}">
-                <a16:creationId xmlns:a16="http://schemas.microsoft.com/office/drawing/2014/main" id="{BCB12ED7-E441-4214-8F80-911B7FD1009B}"/>
+                <a16:creationId xmlns:a16="http://schemas.microsoft.com/office/drawing/2014/main" id="{71C670DE-5722-4DCD-B40E-79ACF1E85109}"/>
               </a:ext>
             </a:extLst>
           </p:cNvPr>
@@ -4138,7 +4138,7 @@
           <p:cNvPr id="20" name="">
             <a:extLst xmlns:a="http://schemas.openxmlformats.org/drawingml/2006/main">
               <a:ext uri="{FF2B5EF4-FFF2-40B4-BE49-F238E27FC236}">
-                <a16:creationId xmlns:a16="http://schemas.microsoft.com/office/drawing/2014/main" id="{6AED07B2-19DB-4EF5-859A-0D67A0EF9BAE}"/>
+                <a16:creationId xmlns:a16="http://schemas.microsoft.com/office/drawing/2014/main" id="{A4FCC5A6-D4A6-4E37-83C4-16E2DD5C2F9C}"/>
               </a:ext>
             </a:extLst>
           </p:cNvPr>
@@ -4202,7 +4202,7 @@
           <p:cNvPr id="21" name="">
             <a:extLst xmlns:a="http://schemas.openxmlformats.org/drawingml/2006/main">
               <a:ext uri="{FF2B5EF4-FFF2-40B4-BE49-F238E27FC236}">
-                <a16:creationId xmlns:a16="http://schemas.microsoft.com/office/drawing/2014/main" id="{71541982-7DB8-488A-A6A4-FF2D360C88EF}"/>
+                <a16:creationId xmlns:a16="http://schemas.microsoft.com/office/drawing/2014/main" id="{650D92C1-9889-4C90-BC0D-F01407FC1A9A}"/>
               </a:ext>
             </a:extLst>
           </p:cNvPr>
@@ -4235,7 +4235,7 @@
           <p:cNvPr id="22" name="">
             <a:extLst xmlns:a="http://schemas.openxmlformats.org/drawingml/2006/main">
               <a:ext uri="{FF2B5EF4-FFF2-40B4-BE49-F238E27FC236}">
-                <a16:creationId xmlns:a16="http://schemas.microsoft.com/office/drawing/2014/main" id="{BA41BB7E-C3CB-439A-B4F5-D984EF964D2D}"/>
+                <a16:creationId xmlns:a16="http://schemas.microsoft.com/office/drawing/2014/main" id="{180AE352-8833-434D-9E20-CDB4C9070F16}"/>
               </a:ext>
             </a:extLst>
           </p:cNvPr>
@@ -4299,7 +4299,7 @@
           <p:cNvPr id="23" name="">
             <a:extLst xmlns:a="http://schemas.openxmlformats.org/drawingml/2006/main">
               <a:ext uri="{FF2B5EF4-FFF2-40B4-BE49-F238E27FC236}">
-                <a16:creationId xmlns:a16="http://schemas.microsoft.com/office/drawing/2014/main" id="{4814606C-C33C-4EE9-8871-40C99695CAEB}"/>
+                <a16:creationId xmlns:a16="http://schemas.microsoft.com/office/drawing/2014/main" id="{C6206334-C91E-41CB-B167-96BE3AC12A18}"/>
               </a:ext>
             </a:extLst>
           </p:cNvPr>
@@ -4332,7 +4332,7 @@
           <p:cNvPr id="24" name="">
             <a:extLst xmlns:a="http://schemas.openxmlformats.org/drawingml/2006/main">
               <a:ext uri="{FF2B5EF4-FFF2-40B4-BE49-F238E27FC236}">
-                <a16:creationId xmlns:a16="http://schemas.microsoft.com/office/drawing/2014/main" id="{1819E70B-F26D-48B2-9ABD-2849EA07834D}"/>
+                <a16:creationId xmlns:a16="http://schemas.microsoft.com/office/drawing/2014/main" id="{1EE07B55-1A24-47D3-9E4C-382F76137370}"/>
               </a:ext>
             </a:extLst>
           </p:cNvPr>
@@ -4396,7 +4396,7 @@
           <p:cNvPr id="25" name="">
             <a:extLst xmlns:a="http://schemas.openxmlformats.org/drawingml/2006/main">
               <a:ext uri="{FF2B5EF4-FFF2-40B4-BE49-F238E27FC236}">
-                <a16:creationId xmlns:a16="http://schemas.microsoft.com/office/drawing/2014/main" id="{3999605E-04A0-4E92-BE51-16CCE2F9D25B}"/>
+                <a16:creationId xmlns:a16="http://schemas.microsoft.com/office/drawing/2014/main" id="{543A514E-8166-4A7C-8FC5-466BC8BFAD88}"/>
               </a:ext>
             </a:extLst>
           </p:cNvPr>
@@ -4429,7 +4429,7 @@
           <p:cNvPr id="26" name="">
             <a:extLst xmlns:a="http://schemas.openxmlformats.org/drawingml/2006/main">
               <a:ext uri="{FF2B5EF4-FFF2-40B4-BE49-F238E27FC236}">
-                <a16:creationId xmlns:a16="http://schemas.microsoft.com/office/drawing/2014/main" id="{E1E657B6-2EB4-4322-A54A-8B308D3D9D98}"/>
+                <a16:creationId xmlns:a16="http://schemas.microsoft.com/office/drawing/2014/main" id="{9191C275-87DD-4AC2-8C54-01F3404FD9CC}"/>
               </a:ext>
             </a:extLst>
           </p:cNvPr>
@@ -4493,7 +4493,7 @@
           <p:cNvPr id="27" name="">
             <a:extLst xmlns:a="http://schemas.openxmlformats.org/drawingml/2006/main">
               <a:ext uri="{FF2B5EF4-FFF2-40B4-BE49-F238E27FC236}">
-                <a16:creationId xmlns:a16="http://schemas.microsoft.com/office/drawing/2014/main" id="{7738ABBC-A888-4E30-A199-72CB37CFC031}"/>
+                <a16:creationId xmlns:a16="http://schemas.microsoft.com/office/drawing/2014/main" id="{1C3B3053-5B28-4F46-85CE-99B020B425C1}"/>
               </a:ext>
             </a:extLst>
           </p:cNvPr>
@@ -4613,7 +4613,7 @@
           <p:cNvPr id="28" name="">
             <a:extLst xmlns:a="http://schemas.openxmlformats.org/drawingml/2006/main">
               <a:ext uri="{FF2B5EF4-FFF2-40B4-BE49-F238E27FC236}">
-                <a16:creationId xmlns:a16="http://schemas.microsoft.com/office/drawing/2014/main" id="{4C21DCE4-49E5-4568-A0E9-2C42C80D9509}"/>
+                <a16:creationId xmlns:a16="http://schemas.microsoft.com/office/drawing/2014/main" id="{9D1503BA-64C8-4C4B-B082-9F30008FD15E}"/>
               </a:ext>
             </a:extLst>
           </p:cNvPr>
@@ -4677,7 +4677,7 @@
           <p:cNvPr id="29" name="">
             <a:extLst xmlns:a="http://schemas.openxmlformats.org/drawingml/2006/main">
               <a:ext uri="{FF2B5EF4-FFF2-40B4-BE49-F238E27FC236}">
-                <a16:creationId xmlns:a16="http://schemas.microsoft.com/office/drawing/2014/main" id="{BA66D0C5-4E2D-44D3-86BA-E789B987FEE5}"/>
+                <a16:creationId xmlns:a16="http://schemas.microsoft.com/office/drawing/2014/main" id="{C7DF24D4-1CF3-4912-8574-D2D93F3CC50F}"/>
               </a:ext>
             </a:extLst>
           </p:cNvPr>
@@ -4739,7 +4739,7 @@
     </p:spTree>
     <p:extLst>
       <p:ext uri="{BB962C8B-B14F-4D97-AF65-F5344CB8AC3E}">
-        <p14:creationId xmlns:p14="http://schemas.microsoft.com/office/powerpoint/2010/main" val="1363263629"/>
+        <p14:creationId xmlns:p14="http://schemas.microsoft.com/office/powerpoint/2010/main" val="1914164728"/>
       </p:ext>
     </p:extLst>
   </p:cSld>
@@ -4763,7 +4763,7 @@
           <p:cNvPr id="1" name="">
             <a:extLst xmlns:a="http://schemas.openxmlformats.org/drawingml/2006/main">
               <a:ext uri="{FF2B5EF4-FFF2-40B4-BE49-F238E27FC236}">
-                <a16:creationId xmlns:a16="http://schemas.microsoft.com/office/drawing/2014/main" id="{D273C7B0-AC29-4AFD-A1F4-B687AB5589D2}"/>
+                <a16:creationId xmlns:a16="http://schemas.microsoft.com/office/drawing/2014/main" id="{CE59BF12-B185-4A2B-9AE9-65DB120B0FC3}"/>
               </a:ext>
             </a:extLst>
           </p:cNvPr>
@@ -4796,7 +4796,7 @@
           <p:cNvPr id="2" name="">
             <a:extLst xmlns:a="http://schemas.openxmlformats.org/drawingml/2006/main">
               <a:ext uri="{FF2B5EF4-FFF2-40B4-BE49-F238E27FC236}">
-                <a16:creationId xmlns:a16="http://schemas.microsoft.com/office/drawing/2014/main" id="{90CAE0D6-1D14-447E-BD41-AF0C0BEE42EF}"/>
+                <a16:creationId xmlns:a16="http://schemas.microsoft.com/office/drawing/2014/main" id="{EFB74879-4BF3-4495-83C7-A2DA489DA08F}"/>
               </a:ext>
             </a:extLst>
           </p:cNvPr>
@@ -4829,7 +4829,7 @@
           <p:cNvPr id="3" name="">
             <a:extLst xmlns:a="http://schemas.openxmlformats.org/drawingml/2006/main">
               <a:ext uri="{FF2B5EF4-FFF2-40B4-BE49-F238E27FC236}">
-                <a16:creationId xmlns:a16="http://schemas.microsoft.com/office/drawing/2014/main" id="{47081574-CA99-435B-A5D4-A4C98A90EEFB}"/>
+                <a16:creationId xmlns:a16="http://schemas.microsoft.com/office/drawing/2014/main" id="{3C298298-AD2D-43D2-8169-B19A6A67E66B}"/>
               </a:ext>
             </a:extLst>
           </p:cNvPr>
@@ -4893,7 +4893,7 @@
           <p:cNvPr id="4" name="">
             <a:extLst xmlns:a="http://schemas.openxmlformats.org/drawingml/2006/main">
               <a:ext uri="{FF2B5EF4-FFF2-40B4-BE49-F238E27FC236}">
-                <a16:creationId xmlns:a16="http://schemas.microsoft.com/office/drawing/2014/main" id="{CF078F6C-F7C9-4570-B199-67DEDEF4D66A}"/>
+                <a16:creationId xmlns:a16="http://schemas.microsoft.com/office/drawing/2014/main" id="{632C602F-39B2-48A7-94B8-6F065C58CEFB}"/>
               </a:ext>
             </a:extLst>
           </p:cNvPr>
@@ -4957,7 +4957,7 @@
           <p:cNvPr id="5" name="">
             <a:extLst xmlns:a="http://schemas.openxmlformats.org/drawingml/2006/main">
               <a:ext uri="{FF2B5EF4-FFF2-40B4-BE49-F238E27FC236}">
-                <a16:creationId xmlns:a16="http://schemas.microsoft.com/office/drawing/2014/main" id="{0E1C1F9C-4D93-446F-8443-8B7CF9845CE3}"/>
+                <a16:creationId xmlns:a16="http://schemas.microsoft.com/office/drawing/2014/main" id="{3A8591F7-C26F-4975-907D-109BBC034949}"/>
               </a:ext>
             </a:extLst>
           </p:cNvPr>
@@ -4990,7 +4990,7 @@
           <p:cNvPr id="6" name="">
             <a:extLst xmlns:a="http://schemas.openxmlformats.org/drawingml/2006/main">
               <a:ext uri="{FF2B5EF4-FFF2-40B4-BE49-F238E27FC236}">
-                <a16:creationId xmlns:a16="http://schemas.microsoft.com/office/drawing/2014/main" id="{24136CEB-CFF1-486A-A521-B8784C7CC78A}"/>
+                <a16:creationId xmlns:a16="http://schemas.microsoft.com/office/drawing/2014/main" id="{3E824FB0-2A17-4F80-A95B-01F117141427}"/>
               </a:ext>
             </a:extLst>
           </p:cNvPr>
@@ -5054,7 +5054,7 @@
           <p:cNvPr id="7" name="">
             <a:extLst xmlns:a="http://schemas.openxmlformats.org/drawingml/2006/main">
               <a:ext uri="{FF2B5EF4-FFF2-40B4-BE49-F238E27FC236}">
-                <a16:creationId xmlns:a16="http://schemas.microsoft.com/office/drawing/2014/main" id="{400614E3-78B5-4C24-841A-8382A12EEF55}"/>
+                <a16:creationId xmlns:a16="http://schemas.microsoft.com/office/drawing/2014/main" id="{CCCC53C9-FC58-4C5B-BD70-8B4CFFC50C4C}"/>
               </a:ext>
             </a:extLst>
           </p:cNvPr>
@@ -5118,7 +5118,7 @@
           <p:cNvPr id="8" name="">
             <a:extLst xmlns:a="http://schemas.openxmlformats.org/drawingml/2006/main">
               <a:ext uri="{FF2B5EF4-FFF2-40B4-BE49-F238E27FC236}">
-                <a16:creationId xmlns:a16="http://schemas.microsoft.com/office/drawing/2014/main" id="{A126235B-D757-41B9-BCA3-57A7DE2E3859}"/>
+                <a16:creationId xmlns:a16="http://schemas.microsoft.com/office/drawing/2014/main" id="{A0632227-DAE7-430F-8574-FEB9E2F9298F}"/>
               </a:ext>
             </a:extLst>
           </p:cNvPr>
@@ -5182,7 +5182,7 @@
           <p:cNvPr id="9" name="">
             <a:extLst xmlns:a="http://schemas.openxmlformats.org/drawingml/2006/main">
               <a:ext uri="{FF2B5EF4-FFF2-40B4-BE49-F238E27FC236}">
-                <a16:creationId xmlns:a16="http://schemas.microsoft.com/office/drawing/2014/main" id="{5F02C605-D1B5-476C-9A37-4321C87479B1}"/>
+                <a16:creationId xmlns:a16="http://schemas.microsoft.com/office/drawing/2014/main" id="{410C6ACA-D5BB-45A9-83ED-3C507F1BD3A0}"/>
               </a:ext>
             </a:extLst>
           </p:cNvPr>
@@ -5246,7 +5246,7 @@
           <p:cNvPr id="10" name="">
             <a:extLst xmlns:a="http://schemas.openxmlformats.org/drawingml/2006/main">
               <a:ext uri="{FF2B5EF4-FFF2-40B4-BE49-F238E27FC236}">
-                <a16:creationId xmlns:a16="http://schemas.microsoft.com/office/drawing/2014/main" id="{640BD0AB-297E-4924-94B1-B406B7042A35}"/>
+                <a16:creationId xmlns:a16="http://schemas.microsoft.com/office/drawing/2014/main" id="{EEFE552D-8D62-495F-AAE4-27CBFEC122EB}"/>
               </a:ext>
             </a:extLst>
           </p:cNvPr>
@@ -5310,7 +5310,7 @@
           <p:cNvPr id="11" name="">
             <a:extLst xmlns:a="http://schemas.openxmlformats.org/drawingml/2006/main">
               <a:ext uri="{FF2B5EF4-FFF2-40B4-BE49-F238E27FC236}">
-                <a16:creationId xmlns:a16="http://schemas.microsoft.com/office/drawing/2014/main" id="{DA563C72-E404-4658-A8FA-306C659DE488}"/>
+                <a16:creationId xmlns:a16="http://schemas.microsoft.com/office/drawing/2014/main" id="{D04832EC-772B-49EE-A8AB-5B3077B6842B}"/>
               </a:ext>
             </a:extLst>
           </p:cNvPr>
@@ -5343,7 +5343,7 @@
           <p:cNvPr id="12" name="">
             <a:extLst xmlns:a="http://schemas.openxmlformats.org/drawingml/2006/main">
               <a:ext uri="{FF2B5EF4-FFF2-40B4-BE49-F238E27FC236}">
-                <a16:creationId xmlns:a16="http://schemas.microsoft.com/office/drawing/2014/main" id="{E95AEF0E-A35B-4C45-B835-B5B965A99D03}"/>
+                <a16:creationId xmlns:a16="http://schemas.microsoft.com/office/drawing/2014/main" id="{543895DA-49CA-4B80-B4F7-AD58E02F1B05}"/>
               </a:ext>
             </a:extLst>
           </p:cNvPr>
@@ -5407,7 +5407,7 @@
           <p:cNvPr id="13" name="">
             <a:extLst xmlns:a="http://schemas.openxmlformats.org/drawingml/2006/main">
               <a:ext uri="{FF2B5EF4-FFF2-40B4-BE49-F238E27FC236}">
-                <a16:creationId xmlns:a16="http://schemas.microsoft.com/office/drawing/2014/main" id="{17474AE3-5BBF-4031-828F-08D03A087576}"/>
+                <a16:creationId xmlns:a16="http://schemas.microsoft.com/office/drawing/2014/main" id="{B0ABC8DE-F24A-4AE5-A2D8-1A23045C18E9}"/>
               </a:ext>
             </a:extLst>
           </p:cNvPr>
@@ -5471,7 +5471,7 @@
           <p:cNvPr id="14" name="">
             <a:extLst xmlns:a="http://schemas.openxmlformats.org/drawingml/2006/main">
               <a:ext uri="{FF2B5EF4-FFF2-40B4-BE49-F238E27FC236}">
-                <a16:creationId xmlns:a16="http://schemas.microsoft.com/office/drawing/2014/main" id="{82B52A89-EA63-47CE-92C4-DC68948C74E8}"/>
+                <a16:creationId xmlns:a16="http://schemas.microsoft.com/office/drawing/2014/main" id="{2DA71928-E29A-4432-BEA4-B7DB023B2FCB}"/>
               </a:ext>
             </a:extLst>
           </p:cNvPr>
@@ -5535,7 +5535,7 @@
           <p:cNvPr id="15" name="">
             <a:extLst xmlns:a="http://schemas.openxmlformats.org/drawingml/2006/main">
               <a:ext uri="{FF2B5EF4-FFF2-40B4-BE49-F238E27FC236}">
-                <a16:creationId xmlns:a16="http://schemas.microsoft.com/office/drawing/2014/main" id="{76443CB5-A23C-4BCB-B08D-A67D3B602B4D}"/>
+                <a16:creationId xmlns:a16="http://schemas.microsoft.com/office/drawing/2014/main" id="{FB589FE7-48D0-4F10-A5D6-1A119B9DF9C6}"/>
               </a:ext>
             </a:extLst>
           </p:cNvPr>
@@ -5599,7 +5599,7 @@
           <p:cNvPr id="16" name="">
             <a:extLst xmlns:a="http://schemas.openxmlformats.org/drawingml/2006/main">
               <a:ext uri="{FF2B5EF4-FFF2-40B4-BE49-F238E27FC236}">
-                <a16:creationId xmlns:a16="http://schemas.microsoft.com/office/drawing/2014/main" id="{5E60880D-1E57-4C8D-BC6A-5EE4F9C5BFF9}"/>
+                <a16:creationId xmlns:a16="http://schemas.microsoft.com/office/drawing/2014/main" id="{E76CCDFA-60F8-4A2D-82D1-EA6F04D10CF3}"/>
               </a:ext>
             </a:extLst>
           </p:cNvPr>
@@ -5663,7 +5663,7 @@
           <p:cNvPr id="17" name="">
             <a:extLst xmlns:a="http://schemas.openxmlformats.org/drawingml/2006/main">
               <a:ext uri="{FF2B5EF4-FFF2-40B4-BE49-F238E27FC236}">
-                <a16:creationId xmlns:a16="http://schemas.microsoft.com/office/drawing/2014/main" id="{F964B4B5-2381-4CA1-B873-450B92C586C6}"/>
+                <a16:creationId xmlns:a16="http://schemas.microsoft.com/office/drawing/2014/main" id="{202B5BD9-C037-4028-9E03-AE849CF05560}"/>
               </a:ext>
             </a:extLst>
           </p:cNvPr>
@@ -5727,7 +5727,7 @@
           <p:cNvPr id="18" name="">
             <a:extLst xmlns:a="http://schemas.openxmlformats.org/drawingml/2006/main">
               <a:ext uri="{FF2B5EF4-FFF2-40B4-BE49-F238E27FC236}">
-                <a16:creationId xmlns:a16="http://schemas.microsoft.com/office/drawing/2014/main" id="{2EA13802-296C-46E5-8455-FB00E7C05C13}"/>
+                <a16:creationId xmlns:a16="http://schemas.microsoft.com/office/drawing/2014/main" id="{343EBC73-70AC-45CD-A0F5-291BBEC216C3}"/>
               </a:ext>
             </a:extLst>
           </p:cNvPr>
@@ -5791,7 +5791,7 @@
           <p:cNvPr id="19" name="">
             <a:extLst xmlns:a="http://schemas.openxmlformats.org/drawingml/2006/main">
               <a:ext uri="{FF2B5EF4-FFF2-40B4-BE49-F238E27FC236}">
-                <a16:creationId xmlns:a16="http://schemas.microsoft.com/office/drawing/2014/main" id="{64B7014A-1F1E-4F37-891A-837D5F6E551D}"/>
+                <a16:creationId xmlns:a16="http://schemas.microsoft.com/office/drawing/2014/main" id="{EC7BBD21-1E3A-4651-A37D-92163D00B760}"/>
               </a:ext>
             </a:extLst>
           </p:cNvPr>
@@ -5855,7 +5855,7 @@
           <p:cNvPr id="20" name="">
             <a:extLst xmlns:a="http://schemas.openxmlformats.org/drawingml/2006/main">
               <a:ext uri="{FF2B5EF4-FFF2-40B4-BE49-F238E27FC236}">
-                <a16:creationId xmlns:a16="http://schemas.microsoft.com/office/drawing/2014/main" id="{EC34322A-31E9-4B54-AFEA-8C1F7C80E526}"/>
+                <a16:creationId xmlns:a16="http://schemas.microsoft.com/office/drawing/2014/main" id="{60D4B820-DA59-48B3-82EE-84638313A925}"/>
               </a:ext>
             </a:extLst>
           </p:cNvPr>
@@ -5888,7 +5888,7 @@
           <p:cNvPr id="21" name="">
             <a:extLst xmlns:a="http://schemas.openxmlformats.org/drawingml/2006/main">
               <a:ext uri="{FF2B5EF4-FFF2-40B4-BE49-F238E27FC236}">
-                <a16:creationId xmlns:a16="http://schemas.microsoft.com/office/drawing/2014/main" id="{164C72CB-DAED-4D06-95F7-CD0D30627AE5}"/>
+                <a16:creationId xmlns:a16="http://schemas.microsoft.com/office/drawing/2014/main" id="{88585A89-282C-410F-A229-02196FCF6F2A}"/>
               </a:ext>
             </a:extLst>
           </p:cNvPr>
@@ -5952,7 +5952,7 @@
           <p:cNvPr id="22" name="">
             <a:extLst xmlns:a="http://schemas.openxmlformats.org/drawingml/2006/main">
               <a:ext uri="{FF2B5EF4-FFF2-40B4-BE49-F238E27FC236}">
-                <a16:creationId xmlns:a16="http://schemas.microsoft.com/office/drawing/2014/main" id="{A3954DF5-6056-4561-964B-7029D87E95D9}"/>
+                <a16:creationId xmlns:a16="http://schemas.microsoft.com/office/drawing/2014/main" id="{75C761A2-D55F-4642-8CEC-778AE3F52E2A}"/>
               </a:ext>
             </a:extLst>
           </p:cNvPr>
@@ -6016,7 +6016,7 @@
           <p:cNvPr id="23" name="">
             <a:extLst xmlns:a="http://schemas.openxmlformats.org/drawingml/2006/main">
               <a:ext uri="{FF2B5EF4-FFF2-40B4-BE49-F238E27FC236}">
-                <a16:creationId xmlns:a16="http://schemas.microsoft.com/office/drawing/2014/main" id="{E11A2F1C-D3D4-44E9-920F-51EAC98ECB0C}"/>
+                <a16:creationId xmlns:a16="http://schemas.microsoft.com/office/drawing/2014/main" id="{B05564D8-4BA9-45B9-AA3B-E3C9A3E424DB}"/>
               </a:ext>
             </a:extLst>
           </p:cNvPr>
@@ -6080,7 +6080,7 @@
           <p:cNvPr id="24" name="">
             <a:extLst xmlns:a="http://schemas.openxmlformats.org/drawingml/2006/main">
               <a:ext uri="{FF2B5EF4-FFF2-40B4-BE49-F238E27FC236}">
-                <a16:creationId xmlns:a16="http://schemas.microsoft.com/office/drawing/2014/main" id="{3F0DD706-3B08-4314-B4E4-8B54A866C573}"/>
+                <a16:creationId xmlns:a16="http://schemas.microsoft.com/office/drawing/2014/main" id="{05D0CE60-BCC7-453B-A792-3F8DCC52A1AD}"/>
               </a:ext>
             </a:extLst>
           </p:cNvPr>
@@ -6144,7 +6144,7 @@
           <p:cNvPr id="25" name="">
             <a:extLst xmlns:a="http://schemas.openxmlformats.org/drawingml/2006/main">
               <a:ext uri="{FF2B5EF4-FFF2-40B4-BE49-F238E27FC236}">
-                <a16:creationId xmlns:a16="http://schemas.microsoft.com/office/drawing/2014/main" id="{F7ECAB5C-2365-410C-9DF8-D5A32D9993B9}"/>
+                <a16:creationId xmlns:a16="http://schemas.microsoft.com/office/drawing/2014/main" id="{10632914-22CB-490C-9926-E55AA6086143}"/>
               </a:ext>
             </a:extLst>
           </p:cNvPr>
@@ -6208,7 +6208,7 @@
           <p:cNvPr id="26" name="">
             <a:extLst xmlns:a="http://schemas.openxmlformats.org/drawingml/2006/main">
               <a:ext uri="{FF2B5EF4-FFF2-40B4-BE49-F238E27FC236}">
-                <a16:creationId xmlns:a16="http://schemas.microsoft.com/office/drawing/2014/main" id="{D7222D66-3CD3-417E-8F07-B782494A6439}"/>
+                <a16:creationId xmlns:a16="http://schemas.microsoft.com/office/drawing/2014/main" id="{30D82E72-173D-4A80-8D38-D69FE59BB9E8}"/>
               </a:ext>
             </a:extLst>
           </p:cNvPr>
@@ -6272,7 +6272,7 @@
           <p:cNvPr id="27" name="">
             <a:extLst xmlns:a="http://schemas.openxmlformats.org/drawingml/2006/main">
               <a:ext uri="{FF2B5EF4-FFF2-40B4-BE49-F238E27FC236}">
-                <a16:creationId xmlns:a16="http://schemas.microsoft.com/office/drawing/2014/main" id="{54B8C8B2-84D0-4E5E-9DD1-6D9641CE1DE6}"/>
+                <a16:creationId xmlns:a16="http://schemas.microsoft.com/office/drawing/2014/main" id="{9B0B65EC-E936-4D04-9FF5-F48B8AF13E1C}"/>
               </a:ext>
             </a:extLst>
           </p:cNvPr>
@@ -6336,7 +6336,7 @@
           <p:cNvPr id="28" name="">
             <a:extLst xmlns:a="http://schemas.openxmlformats.org/drawingml/2006/main">
               <a:ext uri="{FF2B5EF4-FFF2-40B4-BE49-F238E27FC236}">
-                <a16:creationId xmlns:a16="http://schemas.microsoft.com/office/drawing/2014/main" id="{EAAA8F4F-B933-4082-A0BE-256E5E0F4A7A}"/>
+                <a16:creationId xmlns:a16="http://schemas.microsoft.com/office/drawing/2014/main" id="{DAE8AC7B-5EE9-496A-BD6B-70F1384A8322}"/>
               </a:ext>
             </a:extLst>
           </p:cNvPr>
@@ -6400,7 +6400,7 @@
           <p:cNvPr id="29" name="">
             <a:extLst xmlns:a="http://schemas.openxmlformats.org/drawingml/2006/main">
               <a:ext uri="{FF2B5EF4-FFF2-40B4-BE49-F238E27FC236}">
-                <a16:creationId xmlns:a16="http://schemas.microsoft.com/office/drawing/2014/main" id="{1A34A7FA-F4D2-4F8F-A40B-F81CAE8DC986}"/>
+                <a16:creationId xmlns:a16="http://schemas.microsoft.com/office/drawing/2014/main" id="{C5A13194-F3C1-4191-8AE2-58E514CCF393}"/>
               </a:ext>
             </a:extLst>
           </p:cNvPr>
@@ -6433,7 +6433,7 @@
           <p:cNvPr id="30" name="">
             <a:extLst xmlns:a="http://schemas.openxmlformats.org/drawingml/2006/main">
               <a:ext uri="{FF2B5EF4-FFF2-40B4-BE49-F238E27FC236}">
-                <a16:creationId xmlns:a16="http://schemas.microsoft.com/office/drawing/2014/main" id="{9B8613EC-D6C9-45EF-B4F2-5D4618499C92}"/>
+                <a16:creationId xmlns:a16="http://schemas.microsoft.com/office/drawing/2014/main" id="{965030C9-B24F-428C-A519-F6CD957E606A}"/>
               </a:ext>
             </a:extLst>
           </p:cNvPr>
@@ -6497,7 +6497,7 @@
           <p:cNvPr id="31" name="">
             <a:extLst xmlns:a="http://schemas.openxmlformats.org/drawingml/2006/main">
               <a:ext uri="{FF2B5EF4-FFF2-40B4-BE49-F238E27FC236}">
-                <a16:creationId xmlns:a16="http://schemas.microsoft.com/office/drawing/2014/main" id="{6F99707F-CE2C-4DF7-9E7A-E04E8ACB97F4}"/>
+                <a16:creationId xmlns:a16="http://schemas.microsoft.com/office/drawing/2014/main" id="{98150460-C005-4EC4-B9FB-DC464C7D409B}"/>
               </a:ext>
             </a:extLst>
           </p:cNvPr>
@@ -6561,7 +6561,7 @@
           <p:cNvPr id="32" name="">
             <a:extLst xmlns:a="http://schemas.openxmlformats.org/drawingml/2006/main">
               <a:ext uri="{FF2B5EF4-FFF2-40B4-BE49-F238E27FC236}">
-                <a16:creationId xmlns:a16="http://schemas.microsoft.com/office/drawing/2014/main" id="{A8EB2E55-CF0C-4042-8888-3A80146032FC}"/>
+                <a16:creationId xmlns:a16="http://schemas.microsoft.com/office/drawing/2014/main" id="{8D79E99F-0E06-47FB-B0BA-79D7EC1D7F3C}"/>
               </a:ext>
             </a:extLst>
           </p:cNvPr>
@@ -6625,7 +6625,7 @@
           <p:cNvPr id="33" name="">
             <a:extLst xmlns:a="http://schemas.openxmlformats.org/drawingml/2006/main">
               <a:ext uri="{FF2B5EF4-FFF2-40B4-BE49-F238E27FC236}">
-                <a16:creationId xmlns:a16="http://schemas.microsoft.com/office/drawing/2014/main" id="{DB747F6A-0EF0-4AD4-B405-C2B8E96301BE}"/>
+                <a16:creationId xmlns:a16="http://schemas.microsoft.com/office/drawing/2014/main" id="{B874A14E-07FE-4A3E-A0D1-8441A7D86C25}"/>
               </a:ext>
             </a:extLst>
           </p:cNvPr>
@@ -6689,7 +6689,7 @@
           <p:cNvPr id="34" name="">
             <a:extLst xmlns:a="http://schemas.openxmlformats.org/drawingml/2006/main">
               <a:ext uri="{FF2B5EF4-FFF2-40B4-BE49-F238E27FC236}">
-                <a16:creationId xmlns:a16="http://schemas.microsoft.com/office/drawing/2014/main" id="{B0705296-352C-40A9-BD73-129FD994ECF0}"/>
+                <a16:creationId xmlns:a16="http://schemas.microsoft.com/office/drawing/2014/main" id="{D7D60689-FB02-4525-821D-2DF74EEC3267}"/>
               </a:ext>
             </a:extLst>
           </p:cNvPr>
@@ -6753,7 +6753,7 @@
           <p:cNvPr id="35" name="">
             <a:extLst xmlns:a="http://schemas.openxmlformats.org/drawingml/2006/main">
               <a:ext uri="{FF2B5EF4-FFF2-40B4-BE49-F238E27FC236}">
-                <a16:creationId xmlns:a16="http://schemas.microsoft.com/office/drawing/2014/main" id="{1F15117E-25D5-460C-80D4-0C21EB734FC3}"/>
+                <a16:creationId xmlns:a16="http://schemas.microsoft.com/office/drawing/2014/main" id="{F711E9FE-5C0E-46E3-9E39-0A6361DA599E}"/>
               </a:ext>
             </a:extLst>
           </p:cNvPr>
@@ -6817,7 +6817,7 @@
           <p:cNvPr id="36" name="">
             <a:extLst xmlns:a="http://schemas.openxmlformats.org/drawingml/2006/main">
               <a:ext uri="{FF2B5EF4-FFF2-40B4-BE49-F238E27FC236}">
-                <a16:creationId xmlns:a16="http://schemas.microsoft.com/office/drawing/2014/main" id="{1278002A-DDB3-4231-9868-E5CBC383D403}"/>
+                <a16:creationId xmlns:a16="http://schemas.microsoft.com/office/drawing/2014/main" id="{E268AF0C-B49D-4835-9EA3-9DAA45F6106C}"/>
               </a:ext>
             </a:extLst>
           </p:cNvPr>
@@ -6881,7 +6881,7 @@
           <p:cNvPr id="37" name="">
             <a:extLst xmlns:a="http://schemas.openxmlformats.org/drawingml/2006/main">
               <a:ext uri="{FF2B5EF4-FFF2-40B4-BE49-F238E27FC236}">
-                <a16:creationId xmlns:a16="http://schemas.microsoft.com/office/drawing/2014/main" id="{87A95698-22E7-499A-9DB9-DD8D4C82E335}"/>
+                <a16:creationId xmlns:a16="http://schemas.microsoft.com/office/drawing/2014/main" id="{D3987437-03C1-4D28-BFA5-0AEF5B6DD51E}"/>
               </a:ext>
             </a:extLst>
           </p:cNvPr>
@@ -6945,7 +6945,7 @@
           <p:cNvPr id="38" name="">
             <a:extLst xmlns:a="http://schemas.openxmlformats.org/drawingml/2006/main">
               <a:ext uri="{FF2B5EF4-FFF2-40B4-BE49-F238E27FC236}">
-                <a16:creationId xmlns:a16="http://schemas.microsoft.com/office/drawing/2014/main" id="{05BE8B21-F06B-437F-BF9F-7FCFDA96D7B5}"/>
+                <a16:creationId xmlns:a16="http://schemas.microsoft.com/office/drawing/2014/main" id="{1491C753-0F02-486C-86B2-4EF5E6767D31}"/>
               </a:ext>
             </a:extLst>
           </p:cNvPr>
@@ -7009,7 +7009,7 @@
           <p:cNvPr id="39" name="">
             <a:extLst xmlns:a="http://schemas.openxmlformats.org/drawingml/2006/main">
               <a:ext uri="{FF2B5EF4-FFF2-40B4-BE49-F238E27FC236}">
-                <a16:creationId xmlns:a16="http://schemas.microsoft.com/office/drawing/2014/main" id="{B74A947B-E328-43ED-94EB-1970DD49EAEB}"/>
+                <a16:creationId xmlns:a16="http://schemas.microsoft.com/office/drawing/2014/main" id="{DAABBE36-D2BE-4393-8C9A-0011FBE740B1}"/>
               </a:ext>
             </a:extLst>
           </p:cNvPr>
@@ -7073,7 +7073,7 @@
           <p:cNvPr id="40" name="">
             <a:extLst xmlns:a="http://schemas.openxmlformats.org/drawingml/2006/main">
               <a:ext uri="{FF2B5EF4-FFF2-40B4-BE49-F238E27FC236}">
-                <a16:creationId xmlns:a16="http://schemas.microsoft.com/office/drawing/2014/main" id="{B0387105-A549-4E96-8DE0-152211E75164}"/>
+                <a16:creationId xmlns:a16="http://schemas.microsoft.com/office/drawing/2014/main" id="{244FB5B6-ECE2-4FFB-940E-71B62300AC18}"/>
               </a:ext>
             </a:extLst>
           </p:cNvPr>
@@ -7137,7 +7137,7 @@
           <p:cNvPr id="41" name="">
             <a:extLst xmlns:a="http://schemas.openxmlformats.org/drawingml/2006/main">
               <a:ext uri="{FF2B5EF4-FFF2-40B4-BE49-F238E27FC236}">
-                <a16:creationId xmlns:a16="http://schemas.microsoft.com/office/drawing/2014/main" id="{CE57CC54-5C10-436F-A9A1-36B63A3E3155}"/>
+                <a16:creationId xmlns:a16="http://schemas.microsoft.com/office/drawing/2014/main" id="{1F680144-BA04-4D8F-9D1D-EEDBBE42FAF1}"/>
               </a:ext>
             </a:extLst>
           </p:cNvPr>
@@ -7199,7 +7199,7 @@
     </p:spTree>
     <p:extLst>
       <p:ext uri="{BB962C8B-B14F-4D97-AF65-F5344CB8AC3E}">
-        <p14:creationId xmlns:p14="http://schemas.microsoft.com/office/powerpoint/2010/main" val="1278608242"/>
+        <p14:creationId xmlns:p14="http://schemas.microsoft.com/office/powerpoint/2010/main" val="1242797617"/>
       </p:ext>
     </p:extLst>
   </p:cSld>
@@ -7223,7 +7223,7 @@
           <p:cNvPr id="1" name="">
             <a:extLst xmlns:a="http://schemas.openxmlformats.org/drawingml/2006/main">
               <a:ext uri="{FF2B5EF4-FFF2-40B4-BE49-F238E27FC236}">
-                <a16:creationId xmlns:a16="http://schemas.microsoft.com/office/drawing/2014/main" id="{989FE587-E02E-4474-ABA4-F3CD54E174BC}"/>
+                <a16:creationId xmlns:a16="http://schemas.microsoft.com/office/drawing/2014/main" id="{E340837A-DC47-4B63-84FC-1074FE93D61A}"/>
               </a:ext>
             </a:extLst>
           </p:cNvPr>
@@ -7256,7 +7256,7 @@
           <p:cNvPr id="2" name="">
             <a:extLst xmlns:a="http://schemas.openxmlformats.org/drawingml/2006/main">
               <a:ext uri="{FF2B5EF4-FFF2-40B4-BE49-F238E27FC236}">
-                <a16:creationId xmlns:a16="http://schemas.microsoft.com/office/drawing/2014/main" id="{B370C971-3424-405B-88D5-A17249178419}"/>
+                <a16:creationId xmlns:a16="http://schemas.microsoft.com/office/drawing/2014/main" id="{1DC84FF2-831A-4906-B03A-CC256F033C6E}"/>
               </a:ext>
             </a:extLst>
           </p:cNvPr>
@@ -7289,7 +7289,7 @@
           <p:cNvPr id="3" name="">
             <a:extLst xmlns:a="http://schemas.openxmlformats.org/drawingml/2006/main">
               <a:ext uri="{FF2B5EF4-FFF2-40B4-BE49-F238E27FC236}">
-                <a16:creationId xmlns:a16="http://schemas.microsoft.com/office/drawing/2014/main" id="{F3A52465-BE34-44ED-9FE3-813B4FAB6965}"/>
+                <a16:creationId xmlns:a16="http://schemas.microsoft.com/office/drawing/2014/main" id="{3E7BB1EA-B0EB-4647-8123-C148DB93FA27}"/>
               </a:ext>
             </a:extLst>
           </p:cNvPr>
@@ -7353,7 +7353,7 @@
           <p:cNvPr id="4" name="">
             <a:extLst xmlns:a="http://schemas.openxmlformats.org/drawingml/2006/main">
               <a:ext uri="{FF2B5EF4-FFF2-40B4-BE49-F238E27FC236}">
-                <a16:creationId xmlns:a16="http://schemas.microsoft.com/office/drawing/2014/main" id="{903B2B65-41B0-4F50-B941-F0EFAAD194D0}"/>
+                <a16:creationId xmlns:a16="http://schemas.microsoft.com/office/drawing/2014/main" id="{2F46B515-2CF1-4223-9E09-FDEFB0A7EDBA}"/>
               </a:ext>
             </a:extLst>
           </p:cNvPr>
@@ -7417,7 +7417,7 @@
           <p:cNvPr id="5" name="">
             <a:extLst xmlns:a="http://schemas.openxmlformats.org/drawingml/2006/main">
               <a:ext uri="{FF2B5EF4-FFF2-40B4-BE49-F238E27FC236}">
-                <a16:creationId xmlns:a16="http://schemas.microsoft.com/office/drawing/2014/main" id="{10171AC1-5481-40F2-A49B-375A6415E700}"/>
+                <a16:creationId xmlns:a16="http://schemas.microsoft.com/office/drawing/2014/main" id="{EF42ECF5-B049-4B84-A695-A5BD9406D1CC}"/>
               </a:ext>
             </a:extLst>
           </p:cNvPr>
@@ -7450,7 +7450,7 @@
           <p:cNvPr id="6" name="">
             <a:extLst xmlns:a="http://schemas.openxmlformats.org/drawingml/2006/main">
               <a:ext uri="{FF2B5EF4-FFF2-40B4-BE49-F238E27FC236}">
-                <a16:creationId xmlns:a16="http://schemas.microsoft.com/office/drawing/2014/main" id="{6825011B-3DE3-43D9-B9E4-C1244CD9E0AC}"/>
+                <a16:creationId xmlns:a16="http://schemas.microsoft.com/office/drawing/2014/main" id="{4CDA21AE-D713-49F1-B661-6E1FE5703BEC}"/>
               </a:ext>
             </a:extLst>
           </p:cNvPr>
@@ -7514,7 +7514,7 @@
           <p:cNvPr id="7" name="">
             <a:extLst xmlns:a="http://schemas.openxmlformats.org/drawingml/2006/main">
               <a:ext uri="{FF2B5EF4-FFF2-40B4-BE49-F238E27FC236}">
-                <a16:creationId xmlns:a16="http://schemas.microsoft.com/office/drawing/2014/main" id="{72097457-7C9E-4700-B351-A20EF31DE902}"/>
+                <a16:creationId xmlns:a16="http://schemas.microsoft.com/office/drawing/2014/main" id="{A66AB1AD-CB67-417F-8612-94FD7EBEA554}"/>
               </a:ext>
             </a:extLst>
           </p:cNvPr>
@@ -7578,7 +7578,7 @@
           <p:cNvPr id="8" name="">
             <a:extLst xmlns:a="http://schemas.openxmlformats.org/drawingml/2006/main">
               <a:ext uri="{FF2B5EF4-FFF2-40B4-BE49-F238E27FC236}">
-                <a16:creationId xmlns:a16="http://schemas.microsoft.com/office/drawing/2014/main" id="{94B91CF7-EAA9-45D3-949D-5D4629DB9E3A}"/>
+                <a16:creationId xmlns:a16="http://schemas.microsoft.com/office/drawing/2014/main" id="{E23462A4-F315-41CE-8889-D45A6A17EB57}"/>
               </a:ext>
             </a:extLst>
           </p:cNvPr>
@@ -7642,7 +7642,7 @@
           <p:cNvPr id="9" name="">
             <a:extLst xmlns:a="http://schemas.openxmlformats.org/drawingml/2006/main">
               <a:ext uri="{FF2B5EF4-FFF2-40B4-BE49-F238E27FC236}">
-                <a16:creationId xmlns:a16="http://schemas.microsoft.com/office/drawing/2014/main" id="{AB6EF13E-8073-45D3-9ADA-ED58A9066B76}"/>
+                <a16:creationId xmlns:a16="http://schemas.microsoft.com/office/drawing/2014/main" id="{8A5C6984-C78E-4C6F-98BB-BCA1834D8FD4}"/>
               </a:ext>
             </a:extLst>
           </p:cNvPr>
@@ -7675,7 +7675,7 @@
           <p:cNvPr id="10" name="">
             <a:extLst xmlns:a="http://schemas.openxmlformats.org/drawingml/2006/main">
               <a:ext uri="{FF2B5EF4-FFF2-40B4-BE49-F238E27FC236}">
-                <a16:creationId xmlns:a16="http://schemas.microsoft.com/office/drawing/2014/main" id="{1C394125-C417-4AF9-B26F-D7BA8856E09B}"/>
+                <a16:creationId xmlns:a16="http://schemas.microsoft.com/office/drawing/2014/main" id="{92ED5100-4AFD-49F9-BC9D-3339651370D9}"/>
               </a:ext>
             </a:extLst>
           </p:cNvPr>
@@ -7739,7 +7739,7 @@
           <p:cNvPr id="11" name="">
             <a:extLst xmlns:a="http://schemas.openxmlformats.org/drawingml/2006/main">
               <a:ext uri="{FF2B5EF4-FFF2-40B4-BE49-F238E27FC236}">
-                <a16:creationId xmlns:a16="http://schemas.microsoft.com/office/drawing/2014/main" id="{4044CCDF-E4B1-4564-9107-D5531BF79E75}"/>
+                <a16:creationId xmlns:a16="http://schemas.microsoft.com/office/drawing/2014/main" id="{561DD5A9-6384-4A4B-9A30-3A6DF2E249BC}"/>
               </a:ext>
             </a:extLst>
           </p:cNvPr>
@@ -7803,7 +7803,7 @@
           <p:cNvPr id="12" name="">
             <a:extLst xmlns:a="http://schemas.openxmlformats.org/drawingml/2006/main">
               <a:ext uri="{FF2B5EF4-FFF2-40B4-BE49-F238E27FC236}">
-                <a16:creationId xmlns:a16="http://schemas.microsoft.com/office/drawing/2014/main" id="{B3E5A0F1-5E1D-407D-924E-5F1A53A4C600}"/>
+                <a16:creationId xmlns:a16="http://schemas.microsoft.com/office/drawing/2014/main" id="{A4C58FED-BA20-4A81-A8BE-C4EBE50E979D}"/>
               </a:ext>
             </a:extLst>
           </p:cNvPr>
@@ -7867,7 +7867,7 @@
           <p:cNvPr id="13" name="">
             <a:extLst xmlns:a="http://schemas.openxmlformats.org/drawingml/2006/main">
               <a:ext uri="{FF2B5EF4-FFF2-40B4-BE49-F238E27FC236}">
-                <a16:creationId xmlns:a16="http://schemas.microsoft.com/office/drawing/2014/main" id="{55D3D8AF-6806-43DA-903C-FE959BBF1E4B}"/>
+                <a16:creationId xmlns:a16="http://schemas.microsoft.com/office/drawing/2014/main" id="{7C368A71-6D27-48A6-A1EC-3AD8FD48E611}"/>
               </a:ext>
             </a:extLst>
           </p:cNvPr>
@@ -7900,7 +7900,7 @@
           <p:cNvPr id="14" name="">
             <a:extLst xmlns:a="http://schemas.openxmlformats.org/drawingml/2006/main">
               <a:ext uri="{FF2B5EF4-FFF2-40B4-BE49-F238E27FC236}">
-                <a16:creationId xmlns:a16="http://schemas.microsoft.com/office/drawing/2014/main" id="{44BAD831-7910-45AD-BDA8-9F0078A6D3C8}"/>
+                <a16:creationId xmlns:a16="http://schemas.microsoft.com/office/drawing/2014/main" id="{9E939B0C-B920-495C-9BF8-68D2224E6DDC}"/>
               </a:ext>
             </a:extLst>
           </p:cNvPr>
@@ -7964,7 +7964,7 @@
           <p:cNvPr id="15" name="">
             <a:extLst xmlns:a="http://schemas.openxmlformats.org/drawingml/2006/main">
               <a:ext uri="{FF2B5EF4-FFF2-40B4-BE49-F238E27FC236}">
-                <a16:creationId xmlns:a16="http://schemas.microsoft.com/office/drawing/2014/main" id="{F4D1A444-B1D0-4EEF-BA5C-4D8FE3C6BDBA}"/>
+                <a16:creationId xmlns:a16="http://schemas.microsoft.com/office/drawing/2014/main" id="{608A0C8E-D217-4FDE-9B41-A17524E81441}"/>
               </a:ext>
             </a:extLst>
           </p:cNvPr>
@@ -8028,7 +8028,7 @@
           <p:cNvPr id="16" name="">
             <a:extLst xmlns:a="http://schemas.openxmlformats.org/drawingml/2006/main">
               <a:ext uri="{FF2B5EF4-FFF2-40B4-BE49-F238E27FC236}">
-                <a16:creationId xmlns:a16="http://schemas.microsoft.com/office/drawing/2014/main" id="{8F6E9E43-8319-4807-947C-6CC6DB856A5D}"/>
+                <a16:creationId xmlns:a16="http://schemas.microsoft.com/office/drawing/2014/main" id="{CE9E5CC8-ABD5-47EB-AEE5-94C2805717E0}"/>
               </a:ext>
             </a:extLst>
           </p:cNvPr>
@@ -8092,7 +8092,7 @@
           <p:cNvPr id="17" name="">
             <a:extLst xmlns:a="http://schemas.openxmlformats.org/drawingml/2006/main">
               <a:ext uri="{FF2B5EF4-FFF2-40B4-BE49-F238E27FC236}">
-                <a16:creationId xmlns:a16="http://schemas.microsoft.com/office/drawing/2014/main" id="{C903D0D0-E823-4B6B-97D0-BE717550EF3A}"/>
+                <a16:creationId xmlns:a16="http://schemas.microsoft.com/office/drawing/2014/main" id="{037245FB-30BB-4489-9061-5B8913BB8D35}"/>
               </a:ext>
             </a:extLst>
           </p:cNvPr>
@@ -8125,7 +8125,7 @@
           <p:cNvPr id="18" name="">
             <a:extLst xmlns:a="http://schemas.openxmlformats.org/drawingml/2006/main">
               <a:ext uri="{FF2B5EF4-FFF2-40B4-BE49-F238E27FC236}">
-                <a16:creationId xmlns:a16="http://schemas.microsoft.com/office/drawing/2014/main" id="{69B42597-2289-45F6-9E20-C2891CF8C7AA}"/>
+                <a16:creationId xmlns:a16="http://schemas.microsoft.com/office/drawing/2014/main" id="{B5BF7015-A196-4347-8A66-727595116A23}"/>
               </a:ext>
             </a:extLst>
           </p:cNvPr>
@@ -8189,7 +8189,7 @@
           <p:cNvPr id="19" name="">
             <a:extLst xmlns:a="http://schemas.openxmlformats.org/drawingml/2006/main">
               <a:ext uri="{FF2B5EF4-FFF2-40B4-BE49-F238E27FC236}">
-                <a16:creationId xmlns:a16="http://schemas.microsoft.com/office/drawing/2014/main" id="{7679D5A6-9B90-4FC7-AE15-C5BC0EDF7BB2}"/>
+                <a16:creationId xmlns:a16="http://schemas.microsoft.com/office/drawing/2014/main" id="{D8C7DC00-E280-4138-B226-18ECE4E1E9FB}"/>
               </a:ext>
             </a:extLst>
           </p:cNvPr>
@@ -8253,7 +8253,7 @@
           <p:cNvPr id="20" name="">
             <a:extLst xmlns:a="http://schemas.openxmlformats.org/drawingml/2006/main">
               <a:ext uri="{FF2B5EF4-FFF2-40B4-BE49-F238E27FC236}">
-                <a16:creationId xmlns:a16="http://schemas.microsoft.com/office/drawing/2014/main" id="{38AE3BD3-1679-44AC-B1AA-5B905C90C196}"/>
+                <a16:creationId xmlns:a16="http://schemas.microsoft.com/office/drawing/2014/main" id="{763F8528-A360-486C-AA60-DDA78A588031}"/>
               </a:ext>
             </a:extLst>
           </p:cNvPr>
@@ -8317,7 +8317,7 @@
           <p:cNvPr id="21" name="">
             <a:extLst xmlns:a="http://schemas.openxmlformats.org/drawingml/2006/main">
               <a:ext uri="{FF2B5EF4-FFF2-40B4-BE49-F238E27FC236}">
-                <a16:creationId xmlns:a16="http://schemas.microsoft.com/office/drawing/2014/main" id="{751A6DD5-95CD-4EC2-A1C5-7828EFA0F9CA}"/>
+                <a16:creationId xmlns:a16="http://schemas.microsoft.com/office/drawing/2014/main" id="{734B8D55-F061-4162-B337-8FBE5E5ECF69}"/>
               </a:ext>
             </a:extLst>
           </p:cNvPr>
@@ -8381,7 +8381,7 @@
           <p:cNvPr id="22" name="">
             <a:extLst xmlns:a="http://schemas.openxmlformats.org/drawingml/2006/main">
               <a:ext uri="{FF2B5EF4-FFF2-40B4-BE49-F238E27FC236}">
-                <a16:creationId xmlns:a16="http://schemas.microsoft.com/office/drawing/2014/main" id="{D541335E-CC5D-4ECF-954C-F3EF32107E8B}"/>
+                <a16:creationId xmlns:a16="http://schemas.microsoft.com/office/drawing/2014/main" id="{89BE4880-C8C0-4BF0-9623-B6DCDED9C937}"/>
               </a:ext>
             </a:extLst>
           </p:cNvPr>
@@ -8443,7 +8443,7 @@
     </p:spTree>
     <p:extLst>
       <p:ext uri="{BB962C8B-B14F-4D97-AF65-F5344CB8AC3E}">
-        <p14:creationId xmlns:p14="http://schemas.microsoft.com/office/powerpoint/2010/main" val="2099050687"/>
+        <p14:creationId xmlns:p14="http://schemas.microsoft.com/office/powerpoint/2010/main" val="2129688972"/>
       </p:ext>
     </p:extLst>
   </p:cSld>
@@ -8467,7 +8467,7 @@
           <p:cNvPr id="1" name="">
             <a:extLst xmlns:a="http://schemas.openxmlformats.org/drawingml/2006/main">
               <a:ext uri="{FF2B5EF4-FFF2-40B4-BE49-F238E27FC236}">
-                <a16:creationId xmlns:a16="http://schemas.microsoft.com/office/drawing/2014/main" id="{2857D5FE-BB59-40B0-BE71-17F52F9C1CA2}"/>
+                <a16:creationId xmlns:a16="http://schemas.microsoft.com/office/drawing/2014/main" id="{A1F3B9D8-EF29-48EB-88E0-1C9872C3C801}"/>
               </a:ext>
             </a:extLst>
           </p:cNvPr>
@@ -8500,7 +8500,7 @@
           <p:cNvPr id="2" name="">
             <a:extLst xmlns:a="http://schemas.openxmlformats.org/drawingml/2006/main">
               <a:ext uri="{FF2B5EF4-FFF2-40B4-BE49-F238E27FC236}">
-                <a16:creationId xmlns:a16="http://schemas.microsoft.com/office/drawing/2014/main" id="{388FCDBE-4048-48FA-8A2F-11FF04080B99}"/>
+                <a16:creationId xmlns:a16="http://schemas.microsoft.com/office/drawing/2014/main" id="{21C90DE0-C4AF-4DD2-AC95-0F50B2219869}"/>
               </a:ext>
             </a:extLst>
           </p:cNvPr>
@@ -8533,7 +8533,7 @@
           <p:cNvPr id="3" name="">
             <a:extLst xmlns:a="http://schemas.openxmlformats.org/drawingml/2006/main">
               <a:ext uri="{FF2B5EF4-FFF2-40B4-BE49-F238E27FC236}">
-                <a16:creationId xmlns:a16="http://schemas.microsoft.com/office/drawing/2014/main" id="{613AFA15-87F8-441D-A515-59D1B6846DD8}"/>
+                <a16:creationId xmlns:a16="http://schemas.microsoft.com/office/drawing/2014/main" id="{FC5F056C-70BC-4978-978B-75042B5B27ED}"/>
               </a:ext>
             </a:extLst>
           </p:cNvPr>
@@ -8597,7 +8597,7 @@
           <p:cNvPr id="4" name="">
             <a:extLst xmlns:a="http://schemas.openxmlformats.org/drawingml/2006/main">
               <a:ext uri="{FF2B5EF4-FFF2-40B4-BE49-F238E27FC236}">
-                <a16:creationId xmlns:a16="http://schemas.microsoft.com/office/drawing/2014/main" id="{6125C02F-8523-48BE-9051-716EA4C6B507}"/>
+                <a16:creationId xmlns:a16="http://schemas.microsoft.com/office/drawing/2014/main" id="{98CB08EC-AC75-4933-9FAB-617F7D94DF91}"/>
               </a:ext>
             </a:extLst>
           </p:cNvPr>
@@ -8661,7 +8661,7 @@
           <p:cNvPr id="5" name="">
             <a:extLst xmlns:a="http://schemas.openxmlformats.org/drawingml/2006/main">
               <a:ext uri="{FF2B5EF4-FFF2-40B4-BE49-F238E27FC236}">
-                <a16:creationId xmlns:a16="http://schemas.microsoft.com/office/drawing/2014/main" id="{0D94803D-83DB-48D0-AEBB-D0CE6AEEB4EF}"/>
+                <a16:creationId xmlns:a16="http://schemas.microsoft.com/office/drawing/2014/main" id="{431041A5-057F-4AC8-B7C5-53C60A25CEB0}"/>
               </a:ext>
             </a:extLst>
           </p:cNvPr>
@@ -8694,7 +8694,7 @@
           <p:cNvPr id="6" name="">
             <a:extLst xmlns:a="http://schemas.openxmlformats.org/drawingml/2006/main">
               <a:ext uri="{FF2B5EF4-FFF2-40B4-BE49-F238E27FC236}">
-                <a16:creationId xmlns:a16="http://schemas.microsoft.com/office/drawing/2014/main" id="{9DC93C6E-EF63-47CB-843A-65587D46217E}"/>
+                <a16:creationId xmlns:a16="http://schemas.microsoft.com/office/drawing/2014/main" id="{B054BA4D-0D18-45EF-9AF9-D0BCA199B5F8}"/>
               </a:ext>
             </a:extLst>
           </p:cNvPr>
@@ -8758,7 +8758,7 @@
           <p:cNvPr id="7" name="">
             <a:extLst xmlns:a="http://schemas.openxmlformats.org/drawingml/2006/main">
               <a:ext uri="{FF2B5EF4-FFF2-40B4-BE49-F238E27FC236}">
-                <a16:creationId xmlns:a16="http://schemas.microsoft.com/office/drawing/2014/main" id="{E53143D3-11B2-40BE-B76B-78197C96F053}"/>
+                <a16:creationId xmlns:a16="http://schemas.microsoft.com/office/drawing/2014/main" id="{BF1A93A8-000C-4404-849F-8F4B4307EC0B}"/>
               </a:ext>
             </a:extLst>
           </p:cNvPr>
@@ -8822,7 +8822,7 @@
           <p:cNvPr id="8" name="">
             <a:extLst xmlns:a="http://schemas.openxmlformats.org/drawingml/2006/main">
               <a:ext uri="{FF2B5EF4-FFF2-40B4-BE49-F238E27FC236}">
-                <a16:creationId xmlns:a16="http://schemas.microsoft.com/office/drawing/2014/main" id="{E95A5EF2-F582-4685-86BF-0205D2DEA37F}"/>
+                <a16:creationId xmlns:a16="http://schemas.microsoft.com/office/drawing/2014/main" id="{AC156085-3AE3-4D5A-8367-26F1096909AC}"/>
               </a:ext>
             </a:extLst>
           </p:cNvPr>
@@ -8886,7 +8886,7 @@
           <p:cNvPr id="9" name="">
             <a:extLst xmlns:a="http://schemas.openxmlformats.org/drawingml/2006/main">
               <a:ext uri="{FF2B5EF4-FFF2-40B4-BE49-F238E27FC236}">
-                <a16:creationId xmlns:a16="http://schemas.microsoft.com/office/drawing/2014/main" id="{5F27FBD6-7E80-4122-94E5-FFE6EEC60322}"/>
+                <a16:creationId xmlns:a16="http://schemas.microsoft.com/office/drawing/2014/main" id="{EB6DDD0E-9A17-4ED2-9C1A-8E2DE348D561}"/>
               </a:ext>
             </a:extLst>
           </p:cNvPr>
@@ -8950,7 +8950,7 @@
           <p:cNvPr id="10" name="">
             <a:extLst xmlns:a="http://schemas.openxmlformats.org/drawingml/2006/main">
               <a:ext uri="{FF2B5EF4-FFF2-40B4-BE49-F238E27FC236}">
-                <a16:creationId xmlns:a16="http://schemas.microsoft.com/office/drawing/2014/main" id="{E758FE83-1174-4506-A61B-1FBE41924BD7}"/>
+                <a16:creationId xmlns:a16="http://schemas.microsoft.com/office/drawing/2014/main" id="{7C78C464-0E4F-41F9-86E3-3F91A8E66241}"/>
               </a:ext>
             </a:extLst>
           </p:cNvPr>
@@ -9014,7 +9014,7 @@
           <p:cNvPr id="11" name="">
             <a:extLst xmlns:a="http://schemas.openxmlformats.org/drawingml/2006/main">
               <a:ext uri="{FF2B5EF4-FFF2-40B4-BE49-F238E27FC236}">
-                <a16:creationId xmlns:a16="http://schemas.microsoft.com/office/drawing/2014/main" id="{35389AF2-F330-42CF-9944-083CD3310037}"/>
+                <a16:creationId xmlns:a16="http://schemas.microsoft.com/office/drawing/2014/main" id="{B7D935E9-6D59-42B7-88BD-AB1CFEF39075}"/>
               </a:ext>
             </a:extLst>
           </p:cNvPr>
@@ -9078,7 +9078,7 @@
           <p:cNvPr id="12" name="">
             <a:extLst xmlns:a="http://schemas.openxmlformats.org/drawingml/2006/main">
               <a:ext uri="{FF2B5EF4-FFF2-40B4-BE49-F238E27FC236}">
-                <a16:creationId xmlns:a16="http://schemas.microsoft.com/office/drawing/2014/main" id="{7B7C654F-B91C-437C-BA04-23FC01106EDB}"/>
+                <a16:creationId xmlns:a16="http://schemas.microsoft.com/office/drawing/2014/main" id="{E1D55278-3F83-49B3-B491-22493C354630}"/>
               </a:ext>
             </a:extLst>
           </p:cNvPr>
@@ -9142,7 +9142,7 @@
           <p:cNvPr id="13" name="">
             <a:extLst xmlns:a="http://schemas.openxmlformats.org/drawingml/2006/main">
               <a:ext uri="{FF2B5EF4-FFF2-40B4-BE49-F238E27FC236}">
-                <a16:creationId xmlns:a16="http://schemas.microsoft.com/office/drawing/2014/main" id="{7B968308-C070-4C2E-BA12-36F831753A48}"/>
+                <a16:creationId xmlns:a16="http://schemas.microsoft.com/office/drawing/2014/main" id="{0D1B05E5-7A9D-4058-B3CE-84C796C2AE30}"/>
               </a:ext>
             </a:extLst>
           </p:cNvPr>
@@ -9234,7 +9234,7 @@
           <p:cNvPr id="14" name="">
             <a:extLst xmlns:a="http://schemas.openxmlformats.org/drawingml/2006/main">
               <a:ext uri="{FF2B5EF4-FFF2-40B4-BE49-F238E27FC236}">
-                <a16:creationId xmlns:a16="http://schemas.microsoft.com/office/drawing/2014/main" id="{F80BE795-1551-4A48-8CFB-E6A8360250FF}"/>
+                <a16:creationId xmlns:a16="http://schemas.microsoft.com/office/drawing/2014/main" id="{C5904239-2226-47AE-962D-5F6B67ECBE8D}"/>
               </a:ext>
             </a:extLst>
           </p:cNvPr>
@@ -9267,7 +9267,7 @@
           <p:cNvPr id="15" name="">
             <a:extLst xmlns:a="http://schemas.openxmlformats.org/drawingml/2006/main">
               <a:ext uri="{FF2B5EF4-FFF2-40B4-BE49-F238E27FC236}">
-                <a16:creationId xmlns:a16="http://schemas.microsoft.com/office/drawing/2014/main" id="{7271946D-94E2-4655-A0F6-C0DDA79CAFA5}"/>
+                <a16:creationId xmlns:a16="http://schemas.microsoft.com/office/drawing/2014/main" id="{1107A5AE-BE99-455D-9825-31702C728F10}"/>
               </a:ext>
             </a:extLst>
           </p:cNvPr>
@@ -9331,7 +9331,7 @@
           <p:cNvPr id="16" name="">
             <a:extLst xmlns:a="http://schemas.openxmlformats.org/drawingml/2006/main">
               <a:ext uri="{FF2B5EF4-FFF2-40B4-BE49-F238E27FC236}">
-                <a16:creationId xmlns:a16="http://schemas.microsoft.com/office/drawing/2014/main" id="{33468D9E-DCFA-4057-9EFD-AD9FC8F44A04}"/>
+                <a16:creationId xmlns:a16="http://schemas.microsoft.com/office/drawing/2014/main" id="{91446918-80A9-496A-9FCF-6ECC052BE2BB}"/>
               </a:ext>
             </a:extLst>
           </p:cNvPr>
@@ -9395,7 +9395,7 @@
           <p:cNvPr id="17" name="">
             <a:extLst xmlns:a="http://schemas.openxmlformats.org/drawingml/2006/main">
               <a:ext uri="{FF2B5EF4-FFF2-40B4-BE49-F238E27FC236}">
-                <a16:creationId xmlns:a16="http://schemas.microsoft.com/office/drawing/2014/main" id="{5CC505AD-B161-49A2-9313-9B577E73190D}"/>
+                <a16:creationId xmlns:a16="http://schemas.microsoft.com/office/drawing/2014/main" id="{6F2283AB-28B2-402B-B834-0E417D23FA6B}"/>
               </a:ext>
             </a:extLst>
           </p:cNvPr>
@@ -9459,7 +9459,7 @@
           <p:cNvPr id="18" name="">
             <a:extLst xmlns:a="http://schemas.openxmlformats.org/drawingml/2006/main">
               <a:ext uri="{FF2B5EF4-FFF2-40B4-BE49-F238E27FC236}">
-                <a16:creationId xmlns:a16="http://schemas.microsoft.com/office/drawing/2014/main" id="{AA31BEB6-FE9D-4B3F-8193-0B5F8AC4C49B}"/>
+                <a16:creationId xmlns:a16="http://schemas.microsoft.com/office/drawing/2014/main" id="{4837D973-E452-4538-907B-C9F3D3715184}"/>
               </a:ext>
             </a:extLst>
           </p:cNvPr>
@@ -9523,7 +9523,7 @@
           <p:cNvPr id="19" name="">
             <a:extLst xmlns:a="http://schemas.openxmlformats.org/drawingml/2006/main">
               <a:ext uri="{FF2B5EF4-FFF2-40B4-BE49-F238E27FC236}">
-                <a16:creationId xmlns:a16="http://schemas.microsoft.com/office/drawing/2014/main" id="{83D98EF9-AE14-4B35-850E-929DDABDEE2E}"/>
+                <a16:creationId xmlns:a16="http://schemas.microsoft.com/office/drawing/2014/main" id="{76842B50-B378-440F-B7AE-D6332C41D3E7}"/>
               </a:ext>
             </a:extLst>
           </p:cNvPr>
@@ -9587,7 +9587,7 @@
           <p:cNvPr id="20" name="">
             <a:extLst xmlns:a="http://schemas.openxmlformats.org/drawingml/2006/main">
               <a:ext uri="{FF2B5EF4-FFF2-40B4-BE49-F238E27FC236}">
-                <a16:creationId xmlns:a16="http://schemas.microsoft.com/office/drawing/2014/main" id="{D99F9318-8A2D-46E2-9B1C-B305F89EAD48}"/>
+                <a16:creationId xmlns:a16="http://schemas.microsoft.com/office/drawing/2014/main" id="{217E62A2-9E93-4175-B384-03B6FBE02332}"/>
               </a:ext>
             </a:extLst>
           </p:cNvPr>
@@ -9651,7 +9651,7 @@
           <p:cNvPr id="21" name="">
             <a:extLst xmlns:a="http://schemas.openxmlformats.org/drawingml/2006/main">
               <a:ext uri="{FF2B5EF4-FFF2-40B4-BE49-F238E27FC236}">
-                <a16:creationId xmlns:a16="http://schemas.microsoft.com/office/drawing/2014/main" id="{DDEF9C05-0643-452B-A7CA-6452DD72A917}"/>
+                <a16:creationId xmlns:a16="http://schemas.microsoft.com/office/drawing/2014/main" id="{7228343B-B590-4EBA-8DF6-4AD1266EF40D}"/>
               </a:ext>
             </a:extLst>
           </p:cNvPr>
@@ -9715,7 +9715,7 @@
           <p:cNvPr id="22" name="">
             <a:extLst xmlns:a="http://schemas.openxmlformats.org/drawingml/2006/main">
               <a:ext uri="{FF2B5EF4-FFF2-40B4-BE49-F238E27FC236}">
-                <a16:creationId xmlns:a16="http://schemas.microsoft.com/office/drawing/2014/main" id="{B2051ECF-9342-48E8-B4E0-9D238318DF0A}"/>
+                <a16:creationId xmlns:a16="http://schemas.microsoft.com/office/drawing/2014/main" id="{DD8C19E5-2C7F-4906-87F3-4B104A232EDF}"/>
               </a:ext>
             </a:extLst>
           </p:cNvPr>
@@ -9807,7 +9807,7 @@
           <p:cNvPr id="23" name="">
             <a:extLst xmlns:a="http://schemas.openxmlformats.org/drawingml/2006/main">
               <a:ext uri="{FF2B5EF4-FFF2-40B4-BE49-F238E27FC236}">
-                <a16:creationId xmlns:a16="http://schemas.microsoft.com/office/drawing/2014/main" id="{08020277-0A3D-4B52-9A47-A1EF8DD2287F}"/>
+                <a16:creationId xmlns:a16="http://schemas.microsoft.com/office/drawing/2014/main" id="{7582D3B2-D7C9-4E6E-81E7-9E14AE4FD4F6}"/>
               </a:ext>
             </a:extLst>
           </p:cNvPr>
@@ -9871,7 +9871,7 @@
           <p:cNvPr id="24" name="">
             <a:extLst xmlns:a="http://schemas.openxmlformats.org/drawingml/2006/main">
               <a:ext uri="{FF2B5EF4-FFF2-40B4-BE49-F238E27FC236}">
-                <a16:creationId xmlns:a16="http://schemas.microsoft.com/office/drawing/2014/main" id="{00428027-EE80-4139-ADAC-CF76DC1CCE4C}"/>
+                <a16:creationId xmlns:a16="http://schemas.microsoft.com/office/drawing/2014/main" id="{A50FD900-0AF6-4C22-8B1C-89A54C0B3C92}"/>
               </a:ext>
             </a:extLst>
           </p:cNvPr>
@@ -9933,7 +9933,7 @@
     </p:spTree>
     <p:extLst>
       <p:ext uri="{BB962C8B-B14F-4D97-AF65-F5344CB8AC3E}">
-        <p14:creationId xmlns:p14="http://schemas.microsoft.com/office/powerpoint/2010/main" val="153821807"/>
+        <p14:creationId xmlns:p14="http://schemas.microsoft.com/office/powerpoint/2010/main" val="133439590"/>
       </p:ext>
     </p:extLst>
   </p:cSld>
@@ -9957,7 +9957,7 @@
           <p:cNvPr id="1" name="">
             <a:extLst xmlns:a="http://schemas.openxmlformats.org/drawingml/2006/main">
               <a:ext uri="{FF2B5EF4-FFF2-40B4-BE49-F238E27FC236}">
-                <a16:creationId xmlns:a16="http://schemas.microsoft.com/office/drawing/2014/main" id="{9E6CB173-D785-4F46-97FE-2AACF8AA2F3E}"/>
+                <a16:creationId xmlns:a16="http://schemas.microsoft.com/office/drawing/2014/main" id="{4895A92C-7D5D-41E9-A6AA-A3E92B7D8877}"/>
               </a:ext>
             </a:extLst>
           </p:cNvPr>
@@ -9990,7 +9990,7 @@
           <p:cNvPr id="2" name="">
             <a:extLst xmlns:a="http://schemas.openxmlformats.org/drawingml/2006/main">
               <a:ext uri="{FF2B5EF4-FFF2-40B4-BE49-F238E27FC236}">
-                <a16:creationId xmlns:a16="http://schemas.microsoft.com/office/drawing/2014/main" id="{07C740DA-9E4C-4336-92BB-6C2F6D3AD5E1}"/>
+                <a16:creationId xmlns:a16="http://schemas.microsoft.com/office/drawing/2014/main" id="{270CE68F-1DD7-4ACB-8E23-72367BD899EE}"/>
               </a:ext>
             </a:extLst>
           </p:cNvPr>
@@ -10023,7 +10023,7 @@
           <p:cNvPr id="3" name="">
             <a:extLst xmlns:a="http://schemas.openxmlformats.org/drawingml/2006/main">
               <a:ext uri="{FF2B5EF4-FFF2-40B4-BE49-F238E27FC236}">
-                <a16:creationId xmlns:a16="http://schemas.microsoft.com/office/drawing/2014/main" id="{9912D231-AE23-47CC-A4E2-8FFE57091D79}"/>
+                <a16:creationId xmlns:a16="http://schemas.microsoft.com/office/drawing/2014/main" id="{DE654524-EE27-42EF-B475-371F36CA474F}"/>
               </a:ext>
             </a:extLst>
           </p:cNvPr>
@@ -10087,7 +10087,7 @@
           <p:cNvPr id="4" name="">
             <a:extLst xmlns:a="http://schemas.openxmlformats.org/drawingml/2006/main">
               <a:ext uri="{FF2B5EF4-FFF2-40B4-BE49-F238E27FC236}">
-                <a16:creationId xmlns:a16="http://schemas.microsoft.com/office/drawing/2014/main" id="{B1E52E43-74ED-4CD7-A776-31A0C23293BF}"/>
+                <a16:creationId xmlns:a16="http://schemas.microsoft.com/office/drawing/2014/main" id="{DF1F77A9-6D46-41F5-B81B-436965E7D398}"/>
               </a:ext>
             </a:extLst>
           </p:cNvPr>
@@ -10151,7 +10151,7 @@
           <p:cNvPr id="5" name="">
             <a:extLst xmlns:a="http://schemas.openxmlformats.org/drawingml/2006/main">
               <a:ext uri="{FF2B5EF4-FFF2-40B4-BE49-F238E27FC236}">
-                <a16:creationId xmlns:a16="http://schemas.microsoft.com/office/drawing/2014/main" id="{C0ED9021-B904-4668-9CCB-354C7762A2DB}"/>
+                <a16:creationId xmlns:a16="http://schemas.microsoft.com/office/drawing/2014/main" id="{2A3781AD-EE05-476B-B788-A1B5E7B93D7F}"/>
               </a:ext>
             </a:extLst>
           </p:cNvPr>
@@ -10184,7 +10184,7 @@
           <p:cNvPr id="6" name="">
             <a:extLst xmlns:a="http://schemas.openxmlformats.org/drawingml/2006/main">
               <a:ext uri="{FF2B5EF4-FFF2-40B4-BE49-F238E27FC236}">
-                <a16:creationId xmlns:a16="http://schemas.microsoft.com/office/drawing/2014/main" id="{54ED8963-828D-4DAA-9CAC-669BBE6E5ACC}"/>
+                <a16:creationId xmlns:a16="http://schemas.microsoft.com/office/drawing/2014/main" id="{C5F74263-0192-460C-9356-6A1BBE79B3F1}"/>
               </a:ext>
             </a:extLst>
           </p:cNvPr>
@@ -10248,7 +10248,7 @@
           <p:cNvPr id="7" name="">
             <a:extLst xmlns:a="http://schemas.openxmlformats.org/drawingml/2006/main">
               <a:ext uri="{FF2B5EF4-FFF2-40B4-BE49-F238E27FC236}">
-                <a16:creationId xmlns:a16="http://schemas.microsoft.com/office/drawing/2014/main" id="{42419A90-8D8E-4E47-902D-999311C759DB}"/>
+                <a16:creationId xmlns:a16="http://schemas.microsoft.com/office/drawing/2014/main" id="{0EA8C352-1806-4FE2-BB54-B96FAC9C9DF4}"/>
               </a:ext>
             </a:extLst>
           </p:cNvPr>
@@ -10281,7 +10281,7 @@
           <p:cNvPr id="8" name="">
             <a:extLst xmlns:a="http://schemas.openxmlformats.org/drawingml/2006/main">
               <a:ext uri="{FF2B5EF4-FFF2-40B4-BE49-F238E27FC236}">
-                <a16:creationId xmlns:a16="http://schemas.microsoft.com/office/drawing/2014/main" id="{6F90F845-F583-45E3-AFA3-EC6709790BEE}"/>
+                <a16:creationId xmlns:a16="http://schemas.microsoft.com/office/drawing/2014/main" id="{DF4778C3-9EBD-4098-A692-52594866A9B1}"/>
               </a:ext>
             </a:extLst>
           </p:cNvPr>
@@ -10345,7 +10345,7 @@
           <p:cNvPr id="9" name="">
             <a:extLst xmlns:a="http://schemas.openxmlformats.org/drawingml/2006/main">
               <a:ext uri="{FF2B5EF4-FFF2-40B4-BE49-F238E27FC236}">
-                <a16:creationId xmlns:a16="http://schemas.microsoft.com/office/drawing/2014/main" id="{0610D1ED-D3B2-42D7-9C5C-6934F2CF7D4D}"/>
+                <a16:creationId xmlns:a16="http://schemas.microsoft.com/office/drawing/2014/main" id="{4AA96ECC-2946-43E7-B652-1F23041115CF}"/>
               </a:ext>
             </a:extLst>
           </p:cNvPr>
@@ -10378,7 +10378,7 @@
           <p:cNvPr id="10" name="">
             <a:extLst xmlns:a="http://schemas.openxmlformats.org/drawingml/2006/main">
               <a:ext uri="{FF2B5EF4-FFF2-40B4-BE49-F238E27FC236}">
-                <a16:creationId xmlns:a16="http://schemas.microsoft.com/office/drawing/2014/main" id="{6A87DDA9-41A4-40AF-9BD4-B2E29C07773A}"/>
+                <a16:creationId xmlns:a16="http://schemas.microsoft.com/office/drawing/2014/main" id="{4DC6424B-8F44-437E-866C-99C8D70B457B}"/>
               </a:ext>
             </a:extLst>
           </p:cNvPr>
@@ -10442,7 +10442,7 @@
           <p:cNvPr id="11" name="">
             <a:extLst xmlns:a="http://schemas.openxmlformats.org/drawingml/2006/main">
               <a:ext uri="{FF2B5EF4-FFF2-40B4-BE49-F238E27FC236}">
-                <a16:creationId xmlns:a16="http://schemas.microsoft.com/office/drawing/2014/main" id="{334329E8-AE74-481A-97B4-D3BFA9011962}"/>
+                <a16:creationId xmlns:a16="http://schemas.microsoft.com/office/drawing/2014/main" id="{DBD366D5-E2E6-44EB-B893-574E8CD7B7A3}"/>
               </a:ext>
             </a:extLst>
           </p:cNvPr>
@@ -10475,7 +10475,7 @@
           <p:cNvPr id="12" name="">
             <a:extLst xmlns:a="http://schemas.openxmlformats.org/drawingml/2006/main">
               <a:ext uri="{FF2B5EF4-FFF2-40B4-BE49-F238E27FC236}">
-                <a16:creationId xmlns:a16="http://schemas.microsoft.com/office/drawing/2014/main" id="{3153A479-80E3-4138-AA1C-6D4724194FED}"/>
+                <a16:creationId xmlns:a16="http://schemas.microsoft.com/office/drawing/2014/main" id="{FC2EACC7-650B-4D7A-AACE-1C63ADDADBC6}"/>
               </a:ext>
             </a:extLst>
           </p:cNvPr>
@@ -10539,7 +10539,7 @@
           <p:cNvPr id="13" name="">
             <a:extLst xmlns:a="http://schemas.openxmlformats.org/drawingml/2006/main">
               <a:ext uri="{FF2B5EF4-FFF2-40B4-BE49-F238E27FC236}">
-                <a16:creationId xmlns:a16="http://schemas.microsoft.com/office/drawing/2014/main" id="{81DCB2D6-FEA6-4405-9CAC-E8102DE7D54D}"/>
+                <a16:creationId xmlns:a16="http://schemas.microsoft.com/office/drawing/2014/main" id="{E36EB666-E50F-479A-9813-D71CE845BFB8}"/>
               </a:ext>
             </a:extLst>
           </p:cNvPr>
@@ -10572,7 +10572,7 @@
           <p:cNvPr id="14" name="">
             <a:extLst xmlns:a="http://schemas.openxmlformats.org/drawingml/2006/main">
               <a:ext uri="{FF2B5EF4-FFF2-40B4-BE49-F238E27FC236}">
-                <a16:creationId xmlns:a16="http://schemas.microsoft.com/office/drawing/2014/main" id="{743DBD19-59D0-469F-9525-3A189CE2B65F}"/>
+                <a16:creationId xmlns:a16="http://schemas.microsoft.com/office/drawing/2014/main" id="{F1AABCAC-0FB2-4EB2-8C8C-80BCDAD3CC2A}"/>
               </a:ext>
             </a:extLst>
           </p:cNvPr>
@@ -10636,7 +10636,7 @@
           <p:cNvPr id="15" name="">
             <a:extLst xmlns:a="http://schemas.openxmlformats.org/drawingml/2006/main">
               <a:ext uri="{FF2B5EF4-FFF2-40B4-BE49-F238E27FC236}">
-                <a16:creationId xmlns:a16="http://schemas.microsoft.com/office/drawing/2014/main" id="{DDE80389-A7A1-4C96-9485-B391B7A2E366}"/>
+                <a16:creationId xmlns:a16="http://schemas.microsoft.com/office/drawing/2014/main" id="{CAA806B1-2CB7-48B2-BD5B-55F67C8B1C43}"/>
               </a:ext>
             </a:extLst>
           </p:cNvPr>
@@ -10669,7 +10669,7 @@
           <p:cNvPr id="16" name="">
             <a:extLst xmlns:a="http://schemas.openxmlformats.org/drawingml/2006/main">
               <a:ext uri="{FF2B5EF4-FFF2-40B4-BE49-F238E27FC236}">
-                <a16:creationId xmlns:a16="http://schemas.microsoft.com/office/drawing/2014/main" id="{06007640-ABA5-443A-ADF7-69E653E3BB0F}"/>
+                <a16:creationId xmlns:a16="http://schemas.microsoft.com/office/drawing/2014/main" id="{F18B2BC2-9515-4449-BA34-79B73D61EB36}"/>
               </a:ext>
             </a:extLst>
           </p:cNvPr>
@@ -10733,7 +10733,7 @@
           <p:cNvPr id="17" name="">
             <a:extLst xmlns:a="http://schemas.openxmlformats.org/drawingml/2006/main">
               <a:ext uri="{FF2B5EF4-FFF2-40B4-BE49-F238E27FC236}">
-                <a16:creationId xmlns:a16="http://schemas.microsoft.com/office/drawing/2014/main" id="{4243F039-EE18-4436-A6DF-C1C5B3ABC3CB}"/>
+                <a16:creationId xmlns:a16="http://schemas.microsoft.com/office/drawing/2014/main" id="{C2A962A0-99AC-417D-978F-85C5C033422D}"/>
               </a:ext>
             </a:extLst>
           </p:cNvPr>
@@ -10766,7 +10766,7 @@
           <p:cNvPr id="18" name="">
             <a:extLst xmlns:a="http://schemas.openxmlformats.org/drawingml/2006/main">
               <a:ext uri="{FF2B5EF4-FFF2-40B4-BE49-F238E27FC236}">
-                <a16:creationId xmlns:a16="http://schemas.microsoft.com/office/drawing/2014/main" id="{B9CFF583-D902-400C-A7AB-AA2220404C9C}"/>
+                <a16:creationId xmlns:a16="http://schemas.microsoft.com/office/drawing/2014/main" id="{6034F1FA-1114-4ADA-AC6F-E9CF5FE2DCD5}"/>
               </a:ext>
             </a:extLst>
           </p:cNvPr>
@@ -10830,7 +10830,7 @@
           <p:cNvPr id="19" name="">
             <a:extLst xmlns:a="http://schemas.openxmlformats.org/drawingml/2006/main">
               <a:ext uri="{FF2B5EF4-FFF2-40B4-BE49-F238E27FC236}">
-                <a16:creationId xmlns:a16="http://schemas.microsoft.com/office/drawing/2014/main" id="{8069F54E-5900-4103-A76E-5D0EEB9DDC9A}"/>
+                <a16:creationId xmlns:a16="http://schemas.microsoft.com/office/drawing/2014/main" id="{2BD46A9A-49F5-4743-9AF8-EF5DBC914D68}"/>
               </a:ext>
             </a:extLst>
           </p:cNvPr>
@@ -10863,7 +10863,7 @@
           <p:cNvPr id="20" name="">
             <a:extLst xmlns:a="http://schemas.openxmlformats.org/drawingml/2006/main">
               <a:ext uri="{FF2B5EF4-FFF2-40B4-BE49-F238E27FC236}">
-                <a16:creationId xmlns:a16="http://schemas.microsoft.com/office/drawing/2014/main" id="{61F11DBD-9649-4889-9CE4-108C30532665}"/>
+                <a16:creationId xmlns:a16="http://schemas.microsoft.com/office/drawing/2014/main" id="{B2C303F4-327A-4A91-852D-CC07FCDC2917}"/>
               </a:ext>
             </a:extLst>
           </p:cNvPr>
@@ -10927,7 +10927,7 @@
           <p:cNvPr id="21" name="">
             <a:extLst xmlns:a="http://schemas.openxmlformats.org/drawingml/2006/main">
               <a:ext uri="{FF2B5EF4-FFF2-40B4-BE49-F238E27FC236}">
-                <a16:creationId xmlns:a16="http://schemas.microsoft.com/office/drawing/2014/main" id="{6A635E70-9A81-4BA5-B9C2-EF53057E3992}"/>
+                <a16:creationId xmlns:a16="http://schemas.microsoft.com/office/drawing/2014/main" id="{84BD06F5-07A5-45EA-BCB2-AB197FA1375A}"/>
               </a:ext>
             </a:extLst>
           </p:cNvPr>
@@ -10960,7 +10960,7 @@
           <p:cNvPr id="22" name="">
             <a:extLst xmlns:a="http://schemas.openxmlformats.org/drawingml/2006/main">
               <a:ext uri="{FF2B5EF4-FFF2-40B4-BE49-F238E27FC236}">
-                <a16:creationId xmlns:a16="http://schemas.microsoft.com/office/drawing/2014/main" id="{70A1DDA9-F713-4CB0-A85D-2915C73D19BB}"/>
+                <a16:creationId xmlns:a16="http://schemas.microsoft.com/office/drawing/2014/main" id="{99850234-965E-4475-A48E-293C0EC48FF6}"/>
               </a:ext>
             </a:extLst>
           </p:cNvPr>
@@ -11024,7 +11024,7 @@
           <p:cNvPr id="23" name="">
             <a:extLst xmlns:a="http://schemas.openxmlformats.org/drawingml/2006/main">
               <a:ext uri="{FF2B5EF4-FFF2-40B4-BE49-F238E27FC236}">
-                <a16:creationId xmlns:a16="http://schemas.microsoft.com/office/drawing/2014/main" id="{BE61DD8E-3023-4655-A65C-77F1DAD25D32}"/>
+                <a16:creationId xmlns:a16="http://schemas.microsoft.com/office/drawing/2014/main" id="{2A079226-4EFE-49B4-9339-7F0BBDA2DA5C}"/>
               </a:ext>
             </a:extLst>
           </p:cNvPr>
@@ -11057,7 +11057,7 @@
           <p:cNvPr id="24" name="">
             <a:extLst xmlns:a="http://schemas.openxmlformats.org/drawingml/2006/main">
               <a:ext uri="{FF2B5EF4-FFF2-40B4-BE49-F238E27FC236}">
-                <a16:creationId xmlns:a16="http://schemas.microsoft.com/office/drawing/2014/main" id="{42E57CA7-97D7-43A5-9F16-651D7E0610CA}"/>
+                <a16:creationId xmlns:a16="http://schemas.microsoft.com/office/drawing/2014/main" id="{92C75C42-8276-4CE9-AB38-AEC43E44624E}"/>
               </a:ext>
             </a:extLst>
           </p:cNvPr>
@@ -11121,7 +11121,7 @@
           <p:cNvPr id="25" name="">
             <a:extLst xmlns:a="http://schemas.openxmlformats.org/drawingml/2006/main">
               <a:ext uri="{FF2B5EF4-FFF2-40B4-BE49-F238E27FC236}">
-                <a16:creationId xmlns:a16="http://schemas.microsoft.com/office/drawing/2014/main" id="{E04A40A9-9F50-40CA-BF0F-C8036E5DAD4D}"/>
+                <a16:creationId xmlns:a16="http://schemas.microsoft.com/office/drawing/2014/main" id="{391E71F3-D4A7-439A-A796-4A6E243BD9FA}"/>
               </a:ext>
             </a:extLst>
           </p:cNvPr>
@@ -11154,7 +11154,7 @@
           <p:cNvPr id="26" name="">
             <a:extLst xmlns:a="http://schemas.openxmlformats.org/drawingml/2006/main">
               <a:ext uri="{FF2B5EF4-FFF2-40B4-BE49-F238E27FC236}">
-                <a16:creationId xmlns:a16="http://schemas.microsoft.com/office/drawing/2014/main" id="{8A3F703F-2834-47A5-9451-B8B40AE00D4C}"/>
+                <a16:creationId xmlns:a16="http://schemas.microsoft.com/office/drawing/2014/main" id="{3A5C6A46-3BE7-40B1-9B4D-B720016B53F0}"/>
               </a:ext>
             </a:extLst>
           </p:cNvPr>
@@ -11218,7 +11218,7 @@
           <p:cNvPr id="27" name="">
             <a:extLst xmlns:a="http://schemas.openxmlformats.org/drawingml/2006/main">
               <a:ext uri="{FF2B5EF4-FFF2-40B4-BE49-F238E27FC236}">
-                <a16:creationId xmlns:a16="http://schemas.microsoft.com/office/drawing/2014/main" id="{303CD530-AB4C-492D-9BB1-5991DD4BB7AD}"/>
+                <a16:creationId xmlns:a16="http://schemas.microsoft.com/office/drawing/2014/main" id="{5B8F9CDE-5DFF-4B85-88E5-8893A7F7AD04}"/>
               </a:ext>
             </a:extLst>
           </p:cNvPr>
@@ -11251,7 +11251,7 @@
           <p:cNvPr id="28" name="">
             <a:extLst xmlns:a="http://schemas.openxmlformats.org/drawingml/2006/main">
               <a:ext uri="{FF2B5EF4-FFF2-40B4-BE49-F238E27FC236}">
-                <a16:creationId xmlns:a16="http://schemas.microsoft.com/office/drawing/2014/main" id="{717D7208-4CC6-426D-A97E-5DCD4EDB8C63}"/>
+                <a16:creationId xmlns:a16="http://schemas.microsoft.com/office/drawing/2014/main" id="{7B8A3692-E05F-4B80-8079-EC0F0C0ECB73}"/>
               </a:ext>
             </a:extLst>
           </p:cNvPr>
@@ -11315,7 +11315,7 @@
           <p:cNvPr id="29" name="">
             <a:extLst xmlns:a="http://schemas.openxmlformats.org/drawingml/2006/main">
               <a:ext uri="{FF2B5EF4-FFF2-40B4-BE49-F238E27FC236}">
-                <a16:creationId xmlns:a16="http://schemas.microsoft.com/office/drawing/2014/main" id="{81BB5D96-72CF-4616-9602-32181E70F9A8}"/>
+                <a16:creationId xmlns:a16="http://schemas.microsoft.com/office/drawing/2014/main" id="{E64C28AC-15FD-4A37-8463-E6C521D8F809}"/>
               </a:ext>
             </a:extLst>
           </p:cNvPr>
@@ -11379,7 +11379,7 @@
           <p:cNvPr id="30" name="">
             <a:extLst xmlns:a="http://schemas.openxmlformats.org/drawingml/2006/main">
               <a:ext uri="{FF2B5EF4-FFF2-40B4-BE49-F238E27FC236}">
-                <a16:creationId xmlns:a16="http://schemas.microsoft.com/office/drawing/2014/main" id="{75877531-8150-492F-AC39-4455D95F943A}"/>
+                <a16:creationId xmlns:a16="http://schemas.microsoft.com/office/drawing/2014/main" id="{449F5BA5-05E4-4613-B326-FAF94A3EA263}"/>
               </a:ext>
             </a:extLst>
           </p:cNvPr>
@@ -11441,7 +11441,7 @@
     </p:spTree>
     <p:extLst>
       <p:ext uri="{BB962C8B-B14F-4D97-AF65-F5344CB8AC3E}">
-        <p14:creationId xmlns:p14="http://schemas.microsoft.com/office/powerpoint/2010/main" val="1144765023"/>
+        <p14:creationId xmlns:p14="http://schemas.microsoft.com/office/powerpoint/2010/main" val="980805766"/>
       </p:ext>
     </p:extLst>
   </p:cSld>
@@ -11465,7 +11465,7 @@
           <p:cNvPr id="1" name="">
             <a:extLst xmlns:a="http://schemas.openxmlformats.org/drawingml/2006/main">
               <a:ext uri="{FF2B5EF4-FFF2-40B4-BE49-F238E27FC236}">
-                <a16:creationId xmlns:a16="http://schemas.microsoft.com/office/drawing/2014/main" id="{634D0207-06D6-4F48-8DDD-C0A62D5691F6}"/>
+                <a16:creationId xmlns:a16="http://schemas.microsoft.com/office/drawing/2014/main" id="{52529C33-8A9B-4267-8555-CB19EA329E7B}"/>
               </a:ext>
             </a:extLst>
           </p:cNvPr>
@@ -11498,7 +11498,7 @@
           <p:cNvPr id="2" name="">
             <a:extLst xmlns:a="http://schemas.openxmlformats.org/drawingml/2006/main">
               <a:ext uri="{FF2B5EF4-FFF2-40B4-BE49-F238E27FC236}">
-                <a16:creationId xmlns:a16="http://schemas.microsoft.com/office/drawing/2014/main" id="{D404C094-7248-443F-BA5A-057CE7542BFF}"/>
+                <a16:creationId xmlns:a16="http://schemas.microsoft.com/office/drawing/2014/main" id="{C344A755-E07C-4495-820A-F4A40A05F4BD}"/>
               </a:ext>
             </a:extLst>
           </p:cNvPr>
@@ -11531,7 +11531,7 @@
           <p:cNvPr id="3" name="">
             <a:extLst xmlns:a="http://schemas.openxmlformats.org/drawingml/2006/main">
               <a:ext uri="{FF2B5EF4-FFF2-40B4-BE49-F238E27FC236}">
-                <a16:creationId xmlns:a16="http://schemas.microsoft.com/office/drawing/2014/main" id="{36B18975-70D6-419C-B516-4CDE8F983596}"/>
+                <a16:creationId xmlns:a16="http://schemas.microsoft.com/office/drawing/2014/main" id="{72DDA950-0863-4D0C-9088-1351338FE815}"/>
               </a:ext>
             </a:extLst>
           </p:cNvPr>
@@ -11595,7 +11595,7 @@
           <p:cNvPr id="4" name="">
             <a:extLst xmlns:a="http://schemas.openxmlformats.org/drawingml/2006/main">
               <a:ext uri="{FF2B5EF4-FFF2-40B4-BE49-F238E27FC236}">
-                <a16:creationId xmlns:a16="http://schemas.microsoft.com/office/drawing/2014/main" id="{B5211404-7529-4088-A75B-FD5F7B36DBC8}"/>
+                <a16:creationId xmlns:a16="http://schemas.microsoft.com/office/drawing/2014/main" id="{8EDCC147-6C4C-424C-BE96-DF33B3C5E427}"/>
               </a:ext>
             </a:extLst>
           </p:cNvPr>
@@ -11659,7 +11659,7 @@
           <p:cNvPr id="5" name="">
             <a:extLst xmlns:a="http://schemas.openxmlformats.org/drawingml/2006/main">
               <a:ext uri="{FF2B5EF4-FFF2-40B4-BE49-F238E27FC236}">
-                <a16:creationId xmlns:a16="http://schemas.microsoft.com/office/drawing/2014/main" id="{DD19B2DF-ED50-46A1-9453-F109107763FE}"/>
+                <a16:creationId xmlns:a16="http://schemas.microsoft.com/office/drawing/2014/main" id="{BC11F4C8-1A71-47D9-9CEB-ED185E8B010E}"/>
               </a:ext>
             </a:extLst>
           </p:cNvPr>
@@ -11692,7 +11692,7 @@
           <p:cNvPr id="6" name="">
             <a:extLst xmlns:a="http://schemas.openxmlformats.org/drawingml/2006/main">
               <a:ext uri="{FF2B5EF4-FFF2-40B4-BE49-F238E27FC236}">
-                <a16:creationId xmlns:a16="http://schemas.microsoft.com/office/drawing/2014/main" id="{06DEF662-9DB2-412E-B0C8-E6C9183FAD4C}"/>
+                <a16:creationId xmlns:a16="http://schemas.microsoft.com/office/drawing/2014/main" id="{F488AC9F-A65C-4227-BE69-E29763A8A217}"/>
               </a:ext>
             </a:extLst>
           </p:cNvPr>
@@ -11756,7 +11756,7 @@
           <p:cNvPr id="7" name="">
             <a:extLst xmlns:a="http://schemas.openxmlformats.org/drawingml/2006/main">
               <a:ext uri="{FF2B5EF4-FFF2-40B4-BE49-F238E27FC236}">
-                <a16:creationId xmlns:a16="http://schemas.microsoft.com/office/drawing/2014/main" id="{1F6DB9BD-A02D-4955-80E7-8CE72283F4BD}"/>
+                <a16:creationId xmlns:a16="http://schemas.microsoft.com/office/drawing/2014/main" id="{DCF9FCBD-6CC8-4077-8309-914F30AC7C7C}"/>
               </a:ext>
             </a:extLst>
           </p:cNvPr>
@@ -11820,7 +11820,7 @@
           <p:cNvPr id="8" name="">
             <a:extLst xmlns:a="http://schemas.openxmlformats.org/drawingml/2006/main">
               <a:ext uri="{FF2B5EF4-FFF2-40B4-BE49-F238E27FC236}">
-                <a16:creationId xmlns:a16="http://schemas.microsoft.com/office/drawing/2014/main" id="{C3E3652A-D0CF-43F1-B5C5-7A0399E094B8}"/>
+                <a16:creationId xmlns:a16="http://schemas.microsoft.com/office/drawing/2014/main" id="{BE7F0A06-21FE-43E1-95B9-FE73EEEECA1A}"/>
               </a:ext>
             </a:extLst>
           </p:cNvPr>
@@ -11884,7 +11884,7 @@
           <p:cNvPr id="9" name="">
             <a:extLst xmlns:a="http://schemas.openxmlformats.org/drawingml/2006/main">
               <a:ext uri="{FF2B5EF4-FFF2-40B4-BE49-F238E27FC236}">
-                <a16:creationId xmlns:a16="http://schemas.microsoft.com/office/drawing/2014/main" id="{DE620A96-3742-482D-8173-8793731D744A}"/>
+                <a16:creationId xmlns:a16="http://schemas.microsoft.com/office/drawing/2014/main" id="{822DF2ED-1927-4F47-BE3B-15CB2D01E2F8}"/>
               </a:ext>
             </a:extLst>
           </p:cNvPr>
@@ -11948,7 +11948,7 @@
           <p:cNvPr id="10" name="">
             <a:extLst xmlns:a="http://schemas.openxmlformats.org/drawingml/2006/main">
               <a:ext uri="{FF2B5EF4-FFF2-40B4-BE49-F238E27FC236}">
-                <a16:creationId xmlns:a16="http://schemas.microsoft.com/office/drawing/2014/main" id="{D2905850-4C9B-4742-B8D6-55108F3118BE}"/>
+                <a16:creationId xmlns:a16="http://schemas.microsoft.com/office/drawing/2014/main" id="{E640E080-5296-47D4-A4FD-084C354908B5}"/>
               </a:ext>
             </a:extLst>
           </p:cNvPr>
@@ -11981,7 +11981,7 @@
           <p:cNvPr id="11" name="">
             <a:extLst xmlns:a="http://schemas.openxmlformats.org/drawingml/2006/main">
               <a:ext uri="{FF2B5EF4-FFF2-40B4-BE49-F238E27FC236}">
-                <a16:creationId xmlns:a16="http://schemas.microsoft.com/office/drawing/2014/main" id="{BFFF8295-4FA6-4FF0-B60A-D33836D065A5}"/>
+                <a16:creationId xmlns:a16="http://schemas.microsoft.com/office/drawing/2014/main" id="{AD6F4677-D80B-42AF-A8AF-87353ED434BA}"/>
               </a:ext>
             </a:extLst>
           </p:cNvPr>
@@ -12045,7 +12045,7 @@
           <p:cNvPr id="12" name="">
             <a:extLst xmlns:a="http://schemas.openxmlformats.org/drawingml/2006/main">
               <a:ext uri="{FF2B5EF4-FFF2-40B4-BE49-F238E27FC236}">
-                <a16:creationId xmlns:a16="http://schemas.microsoft.com/office/drawing/2014/main" id="{5B69680F-AD2C-46DA-B986-21173A6ABDA7}"/>
+                <a16:creationId xmlns:a16="http://schemas.microsoft.com/office/drawing/2014/main" id="{5E38D647-04E0-4B8C-ABDA-61F0D7266F32}"/>
               </a:ext>
             </a:extLst>
           </p:cNvPr>
@@ -12109,7 +12109,7 @@
           <p:cNvPr id="13" name="">
             <a:extLst xmlns:a="http://schemas.openxmlformats.org/drawingml/2006/main">
               <a:ext uri="{FF2B5EF4-FFF2-40B4-BE49-F238E27FC236}">
-                <a16:creationId xmlns:a16="http://schemas.microsoft.com/office/drawing/2014/main" id="{EDE06BCB-65CD-4959-BAD0-6AF1238B4E15}"/>
+                <a16:creationId xmlns:a16="http://schemas.microsoft.com/office/drawing/2014/main" id="{FF647E40-2256-44E9-9F83-77AB055BF1FE}"/>
               </a:ext>
             </a:extLst>
           </p:cNvPr>
@@ -12173,7 +12173,7 @@
           <p:cNvPr id="14" name="">
             <a:extLst xmlns:a="http://schemas.openxmlformats.org/drawingml/2006/main">
               <a:ext uri="{FF2B5EF4-FFF2-40B4-BE49-F238E27FC236}">
-                <a16:creationId xmlns:a16="http://schemas.microsoft.com/office/drawing/2014/main" id="{31008947-8575-4D44-B364-E880DB952D48}"/>
+                <a16:creationId xmlns:a16="http://schemas.microsoft.com/office/drawing/2014/main" id="{10DCC0B8-0E67-48C6-A795-98484127A464}"/>
               </a:ext>
             </a:extLst>
           </p:cNvPr>
@@ -12237,7 +12237,7 @@
           <p:cNvPr id="15" name="">
             <a:extLst xmlns:a="http://schemas.openxmlformats.org/drawingml/2006/main">
               <a:ext uri="{FF2B5EF4-FFF2-40B4-BE49-F238E27FC236}">
-                <a16:creationId xmlns:a16="http://schemas.microsoft.com/office/drawing/2014/main" id="{7B021DE9-53E2-4F2A-B73B-F746C9BC0780}"/>
+                <a16:creationId xmlns:a16="http://schemas.microsoft.com/office/drawing/2014/main" id="{EE77ECF7-E914-41DA-A009-478F929FE438}"/>
               </a:ext>
             </a:extLst>
           </p:cNvPr>
@@ -12301,7 +12301,7 @@
           <p:cNvPr id="16" name="">
             <a:extLst xmlns:a="http://schemas.openxmlformats.org/drawingml/2006/main">
               <a:ext uri="{FF2B5EF4-FFF2-40B4-BE49-F238E27FC236}">
-                <a16:creationId xmlns:a16="http://schemas.microsoft.com/office/drawing/2014/main" id="{1D816CC7-D99B-40CE-A434-C3083B180310}"/>
+                <a16:creationId xmlns:a16="http://schemas.microsoft.com/office/drawing/2014/main" id="{2D674A16-83F2-452C-A788-E2B2BDA8AB6F}"/>
               </a:ext>
             </a:extLst>
           </p:cNvPr>
@@ -12365,7 +12365,7 @@
           <p:cNvPr id="17" name="">
             <a:extLst xmlns:a="http://schemas.openxmlformats.org/drawingml/2006/main">
               <a:ext uri="{FF2B5EF4-FFF2-40B4-BE49-F238E27FC236}">
-                <a16:creationId xmlns:a16="http://schemas.microsoft.com/office/drawing/2014/main" id="{5DEDACB4-A71D-4821-878F-5583FF91BA91}"/>
+                <a16:creationId xmlns:a16="http://schemas.microsoft.com/office/drawing/2014/main" id="{C31A4B4B-AB2A-4721-ACA8-546671E14B3B}"/>
               </a:ext>
             </a:extLst>
           </p:cNvPr>
@@ -12398,7 +12398,7 @@
           <p:cNvPr id="18" name="">
             <a:extLst xmlns:a="http://schemas.openxmlformats.org/drawingml/2006/main">
               <a:ext uri="{FF2B5EF4-FFF2-40B4-BE49-F238E27FC236}">
-                <a16:creationId xmlns:a16="http://schemas.microsoft.com/office/drawing/2014/main" id="{E9F806ED-D134-476F-829F-8A0EB3CA2DB0}"/>
+                <a16:creationId xmlns:a16="http://schemas.microsoft.com/office/drawing/2014/main" id="{1E9B6EB5-01B3-4BED-B5CC-45CBA90705F7}"/>
               </a:ext>
             </a:extLst>
           </p:cNvPr>
@@ -12462,7 +12462,7 @@
           <p:cNvPr id="19" name="">
             <a:extLst xmlns:a="http://schemas.openxmlformats.org/drawingml/2006/main">
               <a:ext uri="{FF2B5EF4-FFF2-40B4-BE49-F238E27FC236}">
-                <a16:creationId xmlns:a16="http://schemas.microsoft.com/office/drawing/2014/main" id="{B8CACB56-6B31-4C9B-905C-DB8A5AA5C3FE}"/>
+                <a16:creationId xmlns:a16="http://schemas.microsoft.com/office/drawing/2014/main" id="{DA786768-6350-40A5-9790-512194F0933B}"/>
               </a:ext>
             </a:extLst>
           </p:cNvPr>
@@ -12526,7 +12526,7 @@
           <p:cNvPr id="20" name="">
             <a:extLst xmlns:a="http://schemas.openxmlformats.org/drawingml/2006/main">
               <a:ext uri="{FF2B5EF4-FFF2-40B4-BE49-F238E27FC236}">
-                <a16:creationId xmlns:a16="http://schemas.microsoft.com/office/drawing/2014/main" id="{9807AAED-2D01-428C-8155-109DAA49F037}"/>
+                <a16:creationId xmlns:a16="http://schemas.microsoft.com/office/drawing/2014/main" id="{43253CD0-98D7-4779-B76C-895DFEFE78BB}"/>
               </a:ext>
             </a:extLst>
           </p:cNvPr>
@@ -12590,7 +12590,7 @@
           <p:cNvPr id="21" name="">
             <a:extLst xmlns:a="http://schemas.openxmlformats.org/drawingml/2006/main">
               <a:ext uri="{FF2B5EF4-FFF2-40B4-BE49-F238E27FC236}">
-                <a16:creationId xmlns:a16="http://schemas.microsoft.com/office/drawing/2014/main" id="{8C994E60-EA2E-4DFC-9C7B-E5F2740C6602}"/>
+                <a16:creationId xmlns:a16="http://schemas.microsoft.com/office/drawing/2014/main" id="{541624B7-DEC0-470F-81B0-88C2CCCC3333}"/>
               </a:ext>
             </a:extLst>
           </p:cNvPr>
@@ -12654,7 +12654,7 @@
           <p:cNvPr id="22" name="">
             <a:extLst xmlns:a="http://schemas.openxmlformats.org/drawingml/2006/main">
               <a:ext uri="{FF2B5EF4-FFF2-40B4-BE49-F238E27FC236}">
-                <a16:creationId xmlns:a16="http://schemas.microsoft.com/office/drawing/2014/main" id="{8435F685-0BC6-49DE-AE46-BE6E74A71065}"/>
+                <a16:creationId xmlns:a16="http://schemas.microsoft.com/office/drawing/2014/main" id="{8CE43614-13B2-4A8B-8299-FDB174DB3AE7}"/>
               </a:ext>
             </a:extLst>
           </p:cNvPr>
@@ -12718,7 +12718,7 @@
           <p:cNvPr id="23" name="">
             <a:extLst xmlns:a="http://schemas.openxmlformats.org/drawingml/2006/main">
               <a:ext uri="{FF2B5EF4-FFF2-40B4-BE49-F238E27FC236}">
-                <a16:creationId xmlns:a16="http://schemas.microsoft.com/office/drawing/2014/main" id="{5B6BBFA3-AC06-46C8-9B09-F56635483865}"/>
+                <a16:creationId xmlns:a16="http://schemas.microsoft.com/office/drawing/2014/main" id="{3E81C8A2-124B-4611-8476-3CCA8F937A37}"/>
               </a:ext>
             </a:extLst>
           </p:cNvPr>
@@ -12782,7 +12782,7 @@
           <p:cNvPr id="24" name="">
             <a:extLst xmlns:a="http://schemas.openxmlformats.org/drawingml/2006/main">
               <a:ext uri="{FF2B5EF4-FFF2-40B4-BE49-F238E27FC236}">
-                <a16:creationId xmlns:a16="http://schemas.microsoft.com/office/drawing/2014/main" id="{3764B6D3-CE83-439F-AD99-FAB19DE917FC}"/>
+                <a16:creationId xmlns:a16="http://schemas.microsoft.com/office/drawing/2014/main" id="{EC8A017C-CE2F-4308-93D8-9E1C4F201B4C}"/>
               </a:ext>
             </a:extLst>
           </p:cNvPr>
@@ -12815,7 +12815,7 @@
           <p:cNvPr id="25" name="">
             <a:extLst xmlns:a="http://schemas.openxmlformats.org/drawingml/2006/main">
               <a:ext uri="{FF2B5EF4-FFF2-40B4-BE49-F238E27FC236}">
-                <a16:creationId xmlns:a16="http://schemas.microsoft.com/office/drawing/2014/main" id="{87582179-1652-4005-B611-5A2D4E822A22}"/>
+                <a16:creationId xmlns:a16="http://schemas.microsoft.com/office/drawing/2014/main" id="{6FC1D320-8B3D-49DA-8FCD-1A99646FFEB6}"/>
               </a:ext>
             </a:extLst>
           </p:cNvPr>
@@ -12879,7 +12879,7 @@
           <p:cNvPr id="26" name="">
             <a:extLst xmlns:a="http://schemas.openxmlformats.org/drawingml/2006/main">
               <a:ext uri="{FF2B5EF4-FFF2-40B4-BE49-F238E27FC236}">
-                <a16:creationId xmlns:a16="http://schemas.microsoft.com/office/drawing/2014/main" id="{F2DA4DE4-0480-45D3-B5DC-090B15935DD3}"/>
+                <a16:creationId xmlns:a16="http://schemas.microsoft.com/office/drawing/2014/main" id="{15271816-54CF-4C48-8EB3-E86C8E848C53}"/>
               </a:ext>
             </a:extLst>
           </p:cNvPr>
@@ -12943,7 +12943,7 @@
           <p:cNvPr id="27" name="">
             <a:extLst xmlns:a="http://schemas.openxmlformats.org/drawingml/2006/main">
               <a:ext uri="{FF2B5EF4-FFF2-40B4-BE49-F238E27FC236}">
-                <a16:creationId xmlns:a16="http://schemas.microsoft.com/office/drawing/2014/main" id="{34750086-2D67-45BB-ACAD-92B2F6D66C20}"/>
+                <a16:creationId xmlns:a16="http://schemas.microsoft.com/office/drawing/2014/main" id="{6645A8BE-7A0F-46B2-8F0F-648EBF31DA02}"/>
               </a:ext>
             </a:extLst>
           </p:cNvPr>
@@ -13007,7 +13007,7 @@
           <p:cNvPr id="28" name="">
             <a:extLst xmlns:a="http://schemas.openxmlformats.org/drawingml/2006/main">
               <a:ext uri="{FF2B5EF4-FFF2-40B4-BE49-F238E27FC236}">
-                <a16:creationId xmlns:a16="http://schemas.microsoft.com/office/drawing/2014/main" id="{68A499EC-C309-486A-A85E-093812CDF59E}"/>
+                <a16:creationId xmlns:a16="http://schemas.microsoft.com/office/drawing/2014/main" id="{F74ED454-2B41-4DED-80DD-D74D2C309493}"/>
               </a:ext>
             </a:extLst>
           </p:cNvPr>
@@ -13071,7 +13071,7 @@
           <p:cNvPr id="29" name="">
             <a:extLst xmlns:a="http://schemas.openxmlformats.org/drawingml/2006/main">
               <a:ext uri="{FF2B5EF4-FFF2-40B4-BE49-F238E27FC236}">
-                <a16:creationId xmlns:a16="http://schemas.microsoft.com/office/drawing/2014/main" id="{4EBED2B4-2506-4207-A86A-4B0F921864CA}"/>
+                <a16:creationId xmlns:a16="http://schemas.microsoft.com/office/drawing/2014/main" id="{13C3EA22-D656-4C8D-8561-522B34D833A6}"/>
               </a:ext>
             </a:extLst>
           </p:cNvPr>
@@ -13135,7 +13135,7 @@
           <p:cNvPr id="30" name="">
             <a:extLst xmlns:a="http://schemas.openxmlformats.org/drawingml/2006/main">
               <a:ext uri="{FF2B5EF4-FFF2-40B4-BE49-F238E27FC236}">
-                <a16:creationId xmlns:a16="http://schemas.microsoft.com/office/drawing/2014/main" id="{1AF190AD-43C7-45C3-9304-044B89B722C5}"/>
+                <a16:creationId xmlns:a16="http://schemas.microsoft.com/office/drawing/2014/main" id="{FB76E11F-BBC3-40FF-956B-760F857D5284}"/>
               </a:ext>
             </a:extLst>
           </p:cNvPr>
@@ -13199,7 +13199,7 @@
           <p:cNvPr id="31" name="">
             <a:extLst xmlns:a="http://schemas.openxmlformats.org/drawingml/2006/main">
               <a:ext uri="{FF2B5EF4-FFF2-40B4-BE49-F238E27FC236}">
-                <a16:creationId xmlns:a16="http://schemas.microsoft.com/office/drawing/2014/main" id="{339C0B0F-CD38-4178-A2A0-289482B5F488}"/>
+                <a16:creationId xmlns:a16="http://schemas.microsoft.com/office/drawing/2014/main" id="{8B276325-B9D4-4D4B-B8BC-252536D0A1AF}"/>
               </a:ext>
             </a:extLst>
           </p:cNvPr>
@@ -13232,7 +13232,7 @@
           <p:cNvPr id="32" name="">
             <a:extLst xmlns:a="http://schemas.openxmlformats.org/drawingml/2006/main">
               <a:ext uri="{FF2B5EF4-FFF2-40B4-BE49-F238E27FC236}">
-                <a16:creationId xmlns:a16="http://schemas.microsoft.com/office/drawing/2014/main" id="{E19EA79B-FDF8-4388-832F-936037C270B3}"/>
+                <a16:creationId xmlns:a16="http://schemas.microsoft.com/office/drawing/2014/main" id="{C83D0046-799F-4723-8FC3-F0ABF6404036}"/>
               </a:ext>
             </a:extLst>
           </p:cNvPr>
@@ -13296,7 +13296,7 @@
           <p:cNvPr id="33" name="">
             <a:extLst xmlns:a="http://schemas.openxmlformats.org/drawingml/2006/main">
               <a:ext uri="{FF2B5EF4-FFF2-40B4-BE49-F238E27FC236}">
-                <a16:creationId xmlns:a16="http://schemas.microsoft.com/office/drawing/2014/main" id="{59253601-2C69-4EAA-B2D0-D97EF8DC82BF}"/>
+                <a16:creationId xmlns:a16="http://schemas.microsoft.com/office/drawing/2014/main" id="{A274C3B1-75D8-4BA3-82EC-2F2AD88B1FA2}"/>
               </a:ext>
             </a:extLst>
           </p:cNvPr>
@@ -13360,7 +13360,7 @@
           <p:cNvPr id="34" name="">
             <a:extLst xmlns:a="http://schemas.openxmlformats.org/drawingml/2006/main">
               <a:ext uri="{FF2B5EF4-FFF2-40B4-BE49-F238E27FC236}">
-                <a16:creationId xmlns:a16="http://schemas.microsoft.com/office/drawing/2014/main" id="{69754AFA-45E1-4941-B4FF-18C069392E52}"/>
+                <a16:creationId xmlns:a16="http://schemas.microsoft.com/office/drawing/2014/main" id="{2928A161-A7D7-4BB8-9B73-558AD885C8BF}"/>
               </a:ext>
             </a:extLst>
           </p:cNvPr>
@@ -13424,7 +13424,7 @@
           <p:cNvPr id="35" name="">
             <a:extLst xmlns:a="http://schemas.openxmlformats.org/drawingml/2006/main">
               <a:ext uri="{FF2B5EF4-FFF2-40B4-BE49-F238E27FC236}">
-                <a16:creationId xmlns:a16="http://schemas.microsoft.com/office/drawing/2014/main" id="{58B405C2-C878-45AB-B36F-67291F20944F}"/>
+                <a16:creationId xmlns:a16="http://schemas.microsoft.com/office/drawing/2014/main" id="{600E91F5-50C0-4A35-87E4-B94D5D49C81F}"/>
               </a:ext>
             </a:extLst>
           </p:cNvPr>
@@ -13457,7 +13457,7 @@
           <p:cNvPr id="36" name="">
             <a:extLst xmlns:a="http://schemas.openxmlformats.org/drawingml/2006/main">
               <a:ext uri="{FF2B5EF4-FFF2-40B4-BE49-F238E27FC236}">
-                <a16:creationId xmlns:a16="http://schemas.microsoft.com/office/drawing/2014/main" id="{695158EE-1D4F-452D-8D7E-9562BC0E91CD}"/>
+                <a16:creationId xmlns:a16="http://schemas.microsoft.com/office/drawing/2014/main" id="{001186FD-318C-41F7-A112-A8987AC1CF33}"/>
               </a:ext>
             </a:extLst>
           </p:cNvPr>
@@ -13521,7 +13521,7 @@
           <p:cNvPr id="37" name="">
             <a:extLst xmlns:a="http://schemas.openxmlformats.org/drawingml/2006/main">
               <a:ext uri="{FF2B5EF4-FFF2-40B4-BE49-F238E27FC236}">
-                <a16:creationId xmlns:a16="http://schemas.microsoft.com/office/drawing/2014/main" id="{F1AF0303-AF27-4C7C-97C4-A5E77AB92534}"/>
+                <a16:creationId xmlns:a16="http://schemas.microsoft.com/office/drawing/2014/main" id="{BC0845C0-FA8D-4DCC-8E44-5B0776B971B2}"/>
               </a:ext>
             </a:extLst>
           </p:cNvPr>
@@ -13585,7 +13585,7 @@
           <p:cNvPr id="38" name="">
             <a:extLst xmlns:a="http://schemas.openxmlformats.org/drawingml/2006/main">
               <a:ext uri="{FF2B5EF4-FFF2-40B4-BE49-F238E27FC236}">
-                <a16:creationId xmlns:a16="http://schemas.microsoft.com/office/drawing/2014/main" id="{9409F084-1E10-419C-8D6A-FEFA30F2D9AC}"/>
+                <a16:creationId xmlns:a16="http://schemas.microsoft.com/office/drawing/2014/main" id="{7F5798A7-3FE1-43B0-8699-0C3118111F55}"/>
               </a:ext>
             </a:extLst>
           </p:cNvPr>
@@ -13647,7 +13647,7 @@
     </p:spTree>
     <p:extLst>
       <p:ext uri="{BB962C8B-B14F-4D97-AF65-F5344CB8AC3E}">
-        <p14:creationId xmlns:p14="http://schemas.microsoft.com/office/powerpoint/2010/main" val="1183797270"/>
+        <p14:creationId xmlns:p14="http://schemas.microsoft.com/office/powerpoint/2010/main" val="1487001801"/>
       </p:ext>
     </p:extLst>
   </p:cSld>
@@ -13671,7 +13671,7 @@
           <p:cNvPr id="1" name="">
             <a:extLst xmlns:a="http://schemas.openxmlformats.org/drawingml/2006/main">
               <a:ext uri="{FF2B5EF4-FFF2-40B4-BE49-F238E27FC236}">
-                <a16:creationId xmlns:a16="http://schemas.microsoft.com/office/drawing/2014/main" id="{8AE4EDB8-503C-41DF-8642-F5713831E339}"/>
+                <a16:creationId xmlns:a16="http://schemas.microsoft.com/office/drawing/2014/main" id="{07CAB8BF-CF23-40FE-962F-FA9070408150}"/>
               </a:ext>
             </a:extLst>
           </p:cNvPr>
@@ -13704,7 +13704,7 @@
           <p:cNvPr id="2" name="">
             <a:extLst xmlns:a="http://schemas.openxmlformats.org/drawingml/2006/main">
               <a:ext uri="{FF2B5EF4-FFF2-40B4-BE49-F238E27FC236}">
-                <a16:creationId xmlns:a16="http://schemas.microsoft.com/office/drawing/2014/main" id="{EFD1EC34-B074-4BD4-8BC7-236B3DE1D163}"/>
+                <a16:creationId xmlns:a16="http://schemas.microsoft.com/office/drawing/2014/main" id="{4553DF6F-4519-4F99-B345-009290527752}"/>
               </a:ext>
             </a:extLst>
           </p:cNvPr>
@@ -13737,7 +13737,7 @@
           <p:cNvPr id="3" name="">
             <a:extLst xmlns:a="http://schemas.openxmlformats.org/drawingml/2006/main">
               <a:ext uri="{FF2B5EF4-FFF2-40B4-BE49-F238E27FC236}">
-                <a16:creationId xmlns:a16="http://schemas.microsoft.com/office/drawing/2014/main" id="{247582A3-4817-43E6-9C7A-C877A4085C8C}"/>
+                <a16:creationId xmlns:a16="http://schemas.microsoft.com/office/drawing/2014/main" id="{09276720-DE87-4850-978B-6ACC4A80A576}"/>
               </a:ext>
             </a:extLst>
           </p:cNvPr>
@@ -13801,7 +13801,7 @@
           <p:cNvPr id="4" name="">
             <a:extLst xmlns:a="http://schemas.openxmlformats.org/drawingml/2006/main">
               <a:ext uri="{FF2B5EF4-FFF2-40B4-BE49-F238E27FC236}">
-                <a16:creationId xmlns:a16="http://schemas.microsoft.com/office/drawing/2014/main" id="{4D95909D-B4CE-44B8-B11D-666D0D6320DA}"/>
+                <a16:creationId xmlns:a16="http://schemas.microsoft.com/office/drawing/2014/main" id="{45CF8382-7872-482D-830A-7A43EAF4F894}"/>
               </a:ext>
             </a:extLst>
           </p:cNvPr>
@@ -13865,7 +13865,7 @@
           <p:cNvPr id="5" name="">
             <a:extLst xmlns:a="http://schemas.openxmlformats.org/drawingml/2006/main">
               <a:ext uri="{FF2B5EF4-FFF2-40B4-BE49-F238E27FC236}">
-                <a16:creationId xmlns:a16="http://schemas.microsoft.com/office/drawing/2014/main" id="{E6874788-1A28-40AB-BBF6-66EC03835D5A}"/>
+                <a16:creationId xmlns:a16="http://schemas.microsoft.com/office/drawing/2014/main" id="{8D90BEB2-8862-447C-A653-1C9BA560F151}"/>
               </a:ext>
             </a:extLst>
           </p:cNvPr>
@@ -13898,7 +13898,7 @@
           <p:cNvPr id="6" name="">
             <a:extLst xmlns:a="http://schemas.openxmlformats.org/drawingml/2006/main">
               <a:ext uri="{FF2B5EF4-FFF2-40B4-BE49-F238E27FC236}">
-                <a16:creationId xmlns:a16="http://schemas.microsoft.com/office/drawing/2014/main" id="{1111BF07-1C9C-491C-9430-5AF776E90F6B}"/>
+                <a16:creationId xmlns:a16="http://schemas.microsoft.com/office/drawing/2014/main" id="{B757732D-2733-4488-A0E2-14ECC1F4177D}"/>
               </a:ext>
             </a:extLst>
           </p:cNvPr>
@@ -13931,7 +13931,7 @@
           <p:cNvPr id="7" name="">
             <a:extLst xmlns:a="http://schemas.openxmlformats.org/drawingml/2006/main">
               <a:ext uri="{FF2B5EF4-FFF2-40B4-BE49-F238E27FC236}">
-                <a16:creationId xmlns:a16="http://schemas.microsoft.com/office/drawing/2014/main" id="{A44BE19E-7640-4ACB-9CD5-49BF53DA0841}"/>
+                <a16:creationId xmlns:a16="http://schemas.microsoft.com/office/drawing/2014/main" id="{1CED0A63-27DC-467B-80FE-3FF6DD1CCA28}"/>
               </a:ext>
             </a:extLst>
           </p:cNvPr>
@@ -13995,7 +13995,7 @@
           <p:cNvPr id="8" name="">
             <a:extLst xmlns:a="http://schemas.openxmlformats.org/drawingml/2006/main">
               <a:ext uri="{FF2B5EF4-FFF2-40B4-BE49-F238E27FC236}">
-                <a16:creationId xmlns:a16="http://schemas.microsoft.com/office/drawing/2014/main" id="{BB79BE31-A847-4DD6-8CAB-9DFD6E7C73E3}"/>
+                <a16:creationId xmlns:a16="http://schemas.microsoft.com/office/drawing/2014/main" id="{756D6385-EEC4-4686-8D37-F4B8218175F2}"/>
               </a:ext>
             </a:extLst>
           </p:cNvPr>
@@ -14059,7 +14059,7 @@
           <p:cNvPr id="9" name="">
             <a:extLst xmlns:a="http://schemas.openxmlformats.org/drawingml/2006/main">
               <a:ext uri="{FF2B5EF4-FFF2-40B4-BE49-F238E27FC236}">
-                <a16:creationId xmlns:a16="http://schemas.microsoft.com/office/drawing/2014/main" id="{6E434F2C-9E54-47D3-B56F-601842C1B08A}"/>
+                <a16:creationId xmlns:a16="http://schemas.microsoft.com/office/drawing/2014/main" id="{3980A1F0-171B-4F90-9E6E-2CC1C3F7513F}"/>
               </a:ext>
             </a:extLst>
           </p:cNvPr>
@@ -14123,7 +14123,7 @@
           <p:cNvPr id="10" name="">
             <a:extLst xmlns:a="http://schemas.openxmlformats.org/drawingml/2006/main">
               <a:ext uri="{FF2B5EF4-FFF2-40B4-BE49-F238E27FC236}">
-                <a16:creationId xmlns:a16="http://schemas.microsoft.com/office/drawing/2014/main" id="{2442AC90-5DF3-4839-BBD8-BA699EDECB3C}"/>
+                <a16:creationId xmlns:a16="http://schemas.microsoft.com/office/drawing/2014/main" id="{FD4DF9A2-8AD8-479B-9B3C-8F4A7D7949E6}"/>
               </a:ext>
             </a:extLst>
           </p:cNvPr>
@@ -14156,7 +14156,7 @@
           <p:cNvPr id="11" name="">
             <a:extLst xmlns:a="http://schemas.openxmlformats.org/drawingml/2006/main">
               <a:ext uri="{FF2B5EF4-FFF2-40B4-BE49-F238E27FC236}">
-                <a16:creationId xmlns:a16="http://schemas.microsoft.com/office/drawing/2014/main" id="{2958EC02-B7D0-402E-A025-39858CF3CB03}"/>
+                <a16:creationId xmlns:a16="http://schemas.microsoft.com/office/drawing/2014/main" id="{890DA7CA-4AD6-445B-A80D-3ED9D3298907}"/>
               </a:ext>
             </a:extLst>
           </p:cNvPr>
@@ -14189,7 +14189,7 @@
           <p:cNvPr id="12" name="">
             <a:extLst xmlns:a="http://schemas.openxmlformats.org/drawingml/2006/main">
               <a:ext uri="{FF2B5EF4-FFF2-40B4-BE49-F238E27FC236}">
-                <a16:creationId xmlns:a16="http://schemas.microsoft.com/office/drawing/2014/main" id="{032302D9-AE22-4170-9906-89AC62457890}"/>
+                <a16:creationId xmlns:a16="http://schemas.microsoft.com/office/drawing/2014/main" id="{3EAD34A1-D4F4-4C92-9206-6473A1CE8FD9}"/>
               </a:ext>
             </a:extLst>
           </p:cNvPr>
@@ -14253,7 +14253,7 @@
           <p:cNvPr id="13" name="">
             <a:extLst xmlns:a="http://schemas.openxmlformats.org/drawingml/2006/main">
               <a:ext uri="{FF2B5EF4-FFF2-40B4-BE49-F238E27FC236}">
-                <a16:creationId xmlns:a16="http://schemas.microsoft.com/office/drawing/2014/main" id="{06DAC772-5EDA-41C1-9CF9-995C4C8BD3B3}"/>
+                <a16:creationId xmlns:a16="http://schemas.microsoft.com/office/drawing/2014/main" id="{8536E7B4-A371-42BF-BDC5-3BF95ADEBFC1}"/>
               </a:ext>
             </a:extLst>
           </p:cNvPr>
@@ -14317,7 +14317,7 @@
           <p:cNvPr id="14" name="">
             <a:extLst xmlns:a="http://schemas.openxmlformats.org/drawingml/2006/main">
               <a:ext uri="{FF2B5EF4-FFF2-40B4-BE49-F238E27FC236}">
-                <a16:creationId xmlns:a16="http://schemas.microsoft.com/office/drawing/2014/main" id="{8E958809-49AB-4832-A183-7EDCC255BC06}"/>
+                <a16:creationId xmlns:a16="http://schemas.microsoft.com/office/drawing/2014/main" id="{570B4C0D-29FA-43DF-B5CD-753C7C652D17}"/>
               </a:ext>
             </a:extLst>
           </p:cNvPr>
@@ -14381,7 +14381,7 @@
           <p:cNvPr id="15" name="">
             <a:extLst xmlns:a="http://schemas.openxmlformats.org/drawingml/2006/main">
               <a:ext uri="{FF2B5EF4-FFF2-40B4-BE49-F238E27FC236}">
-                <a16:creationId xmlns:a16="http://schemas.microsoft.com/office/drawing/2014/main" id="{8DF8A9A3-5ACC-49CC-A67D-85EE95514556}"/>
+                <a16:creationId xmlns:a16="http://schemas.microsoft.com/office/drawing/2014/main" id="{682A2DEC-7B40-41F1-868C-3B31E4850422}"/>
               </a:ext>
             </a:extLst>
           </p:cNvPr>
@@ -14414,7 +14414,7 @@
           <p:cNvPr id="16" name="">
             <a:extLst xmlns:a="http://schemas.openxmlformats.org/drawingml/2006/main">
               <a:ext uri="{FF2B5EF4-FFF2-40B4-BE49-F238E27FC236}">
-                <a16:creationId xmlns:a16="http://schemas.microsoft.com/office/drawing/2014/main" id="{07CD7525-F22C-48CC-AB77-F054B8D43B0C}"/>
+                <a16:creationId xmlns:a16="http://schemas.microsoft.com/office/drawing/2014/main" id="{8C804615-9F16-4823-9C92-6A4D44B6728F}"/>
               </a:ext>
             </a:extLst>
           </p:cNvPr>
@@ -14447,7 +14447,7 @@
           <p:cNvPr id="17" name="">
             <a:extLst xmlns:a="http://schemas.openxmlformats.org/drawingml/2006/main">
               <a:ext uri="{FF2B5EF4-FFF2-40B4-BE49-F238E27FC236}">
-                <a16:creationId xmlns:a16="http://schemas.microsoft.com/office/drawing/2014/main" id="{063DFB64-4FB0-48EB-AF5A-80A7B277AC42}"/>
+                <a16:creationId xmlns:a16="http://schemas.microsoft.com/office/drawing/2014/main" id="{AA0FD38C-1D9E-4E75-B728-525B6C3CF80D}"/>
               </a:ext>
             </a:extLst>
           </p:cNvPr>
@@ -14511,7 +14511,7 @@
           <p:cNvPr id="18" name="">
             <a:extLst xmlns:a="http://schemas.openxmlformats.org/drawingml/2006/main">
               <a:ext uri="{FF2B5EF4-FFF2-40B4-BE49-F238E27FC236}">
-                <a16:creationId xmlns:a16="http://schemas.microsoft.com/office/drawing/2014/main" id="{4914FC59-E5B3-4656-9242-B3EC2D1D41BF}"/>
+                <a16:creationId xmlns:a16="http://schemas.microsoft.com/office/drawing/2014/main" id="{38448B90-87AA-4A41-9ECD-680014A2D3F8}"/>
               </a:ext>
             </a:extLst>
           </p:cNvPr>
@@ -14575,7 +14575,7 @@
           <p:cNvPr id="19" name="">
             <a:extLst xmlns:a="http://schemas.openxmlformats.org/drawingml/2006/main">
               <a:ext uri="{FF2B5EF4-FFF2-40B4-BE49-F238E27FC236}">
-                <a16:creationId xmlns:a16="http://schemas.microsoft.com/office/drawing/2014/main" id="{CC94781C-E597-4B97-BFD8-8FD03D600F2B}"/>
+                <a16:creationId xmlns:a16="http://schemas.microsoft.com/office/drawing/2014/main" id="{705AE547-4DFE-4D5D-B779-1165F377F893}"/>
               </a:ext>
             </a:extLst>
           </p:cNvPr>
@@ -14639,7 +14639,7 @@
           <p:cNvPr id="20" name="">
             <a:extLst xmlns:a="http://schemas.openxmlformats.org/drawingml/2006/main">
               <a:ext uri="{FF2B5EF4-FFF2-40B4-BE49-F238E27FC236}">
-                <a16:creationId xmlns:a16="http://schemas.microsoft.com/office/drawing/2014/main" id="{7B22F8F1-D450-4BBD-99BE-9BA1F5494B95}"/>
+                <a16:creationId xmlns:a16="http://schemas.microsoft.com/office/drawing/2014/main" id="{A5B16588-C228-438C-999C-B8388E652434}"/>
               </a:ext>
             </a:extLst>
           </p:cNvPr>
@@ -14672,7 +14672,7 @@
           <p:cNvPr id="21" name="">
             <a:extLst xmlns:a="http://schemas.openxmlformats.org/drawingml/2006/main">
               <a:ext uri="{FF2B5EF4-FFF2-40B4-BE49-F238E27FC236}">
-                <a16:creationId xmlns:a16="http://schemas.microsoft.com/office/drawing/2014/main" id="{2D5EB702-3129-4EEC-BBBC-61C9D84152E5}"/>
+                <a16:creationId xmlns:a16="http://schemas.microsoft.com/office/drawing/2014/main" id="{EBBCF5C8-FF64-4C74-988F-426FD4AA48EB}"/>
               </a:ext>
             </a:extLst>
           </p:cNvPr>
@@ -14736,7 +14736,7 @@
           <p:cNvPr id="22" name="">
             <a:extLst xmlns:a="http://schemas.openxmlformats.org/drawingml/2006/main">
               <a:ext uri="{FF2B5EF4-FFF2-40B4-BE49-F238E27FC236}">
-                <a16:creationId xmlns:a16="http://schemas.microsoft.com/office/drawing/2014/main" id="{00772C54-2189-4CBC-948F-4128AFF340F6}"/>
+                <a16:creationId xmlns:a16="http://schemas.microsoft.com/office/drawing/2014/main" id="{7607D4E3-9E12-4F0D-B2FA-8B0F29821DE0}"/>
               </a:ext>
             </a:extLst>
           </p:cNvPr>
@@ -14800,7 +14800,7 @@
           <p:cNvPr id="23" name="">
             <a:extLst xmlns:a="http://schemas.openxmlformats.org/drawingml/2006/main">
               <a:ext uri="{FF2B5EF4-FFF2-40B4-BE49-F238E27FC236}">
-                <a16:creationId xmlns:a16="http://schemas.microsoft.com/office/drawing/2014/main" id="{1DA39E90-8E7F-48A4-BEC5-26B6102A8FEC}"/>
+                <a16:creationId xmlns:a16="http://schemas.microsoft.com/office/drawing/2014/main" id="{35A39C89-8416-4D7F-8F10-8A02F8CF66C1}"/>
               </a:ext>
             </a:extLst>
           </p:cNvPr>
@@ -14862,7 +14862,7 @@
     </p:spTree>
     <p:extLst>
       <p:ext uri="{BB962C8B-B14F-4D97-AF65-F5344CB8AC3E}">
-        <p14:creationId xmlns:p14="http://schemas.microsoft.com/office/powerpoint/2010/main" val="672832085"/>
+        <p14:creationId xmlns:p14="http://schemas.microsoft.com/office/powerpoint/2010/main" val="1648375040"/>
       </p:ext>
     </p:extLst>
   </p:cSld>
@@ -14890,7 +14890,7 @@
           <p:nvPr/>
         </p:nvPicPr>
         <p:blipFill>
-          <a:blip xmlns:r="http://schemas.openxmlformats.org/officeDocument/2006/relationships" xmlns:a="http://schemas.openxmlformats.org/drawingml/2006/main" r:embed="Rcd73e893992f4aaf"/>
+          <a:blip xmlns:r="http://schemas.openxmlformats.org/officeDocument/2006/relationships" xmlns:a="http://schemas.openxmlformats.org/drawingml/2006/main" r:embed="R6df72b58b30249b5"/>
           <a:srcRect xmlns:a="http://schemas.openxmlformats.org/drawingml/2006/main" l="0" t="27" r="0" b="27"/>
           <a:stretch xmlns:a="http://schemas.openxmlformats.org/drawingml/2006/main">
             <a:fillRect l="0" t="0" r="0" b="0"/>
@@ -14911,7 +14911,7 @@
           <p:cNvPr id="2" name="">
             <a:extLst xmlns:a="http://schemas.openxmlformats.org/drawingml/2006/main">
               <a:ext uri="{FF2B5EF4-FFF2-40B4-BE49-F238E27FC236}">
-                <a16:creationId xmlns:a16="http://schemas.microsoft.com/office/drawing/2014/main" id="{E08A77CD-044B-4949-86E6-B3B4C5197D3B}"/>
+                <a16:creationId xmlns:a16="http://schemas.microsoft.com/office/drawing/2014/main" id="{6A99C74C-094B-4BB8-A3F8-08C6E319C67C}"/>
               </a:ext>
             </a:extLst>
           </p:cNvPr>
@@ -14948,7 +14948,7 @@
           <p:cNvPr id="3" name="">
             <a:extLst xmlns:a="http://schemas.openxmlformats.org/drawingml/2006/main">
               <a:ext uri="{FF2B5EF4-FFF2-40B4-BE49-F238E27FC236}">
-                <a16:creationId xmlns:a16="http://schemas.microsoft.com/office/drawing/2014/main" id="{1B0B001A-29C0-44B5-ACA7-D412DB8E5F9E}"/>
+                <a16:creationId xmlns:a16="http://schemas.microsoft.com/office/drawing/2014/main" id="{3606A461-8FDD-4CBB-83AC-5D6FC40457A2}"/>
               </a:ext>
             </a:extLst>
           </p:cNvPr>
@@ -15012,7 +15012,7 @@
           <p:cNvPr id="4" name="">
             <a:extLst xmlns:a="http://schemas.openxmlformats.org/drawingml/2006/main">
               <a:ext uri="{FF2B5EF4-FFF2-40B4-BE49-F238E27FC236}">
-                <a16:creationId xmlns:a16="http://schemas.microsoft.com/office/drawing/2014/main" id="{C3FB9C77-50A5-43BF-BA38-521289BA376B}"/>
+                <a16:creationId xmlns:a16="http://schemas.microsoft.com/office/drawing/2014/main" id="{D65C3A71-D2AF-4970-B219-434C2486633B}"/>
               </a:ext>
             </a:extLst>
           </p:cNvPr>
@@ -15076,7 +15076,7 @@
           <p:cNvPr id="5" name="">
             <a:extLst xmlns:a="http://schemas.openxmlformats.org/drawingml/2006/main">
               <a:ext uri="{FF2B5EF4-FFF2-40B4-BE49-F238E27FC236}">
-                <a16:creationId xmlns:a16="http://schemas.microsoft.com/office/drawing/2014/main" id="{70B4B75B-FAA9-4CA5-B43A-DB5F134A4496}"/>
+                <a16:creationId xmlns:a16="http://schemas.microsoft.com/office/drawing/2014/main" id="{C8CB653E-B4B4-4F3B-934B-062A707DBBB5}"/>
               </a:ext>
             </a:extLst>
           </p:cNvPr>
@@ -15140,7 +15140,7 @@
           <p:cNvPr id="6" name="">
             <a:extLst xmlns:a="http://schemas.openxmlformats.org/drawingml/2006/main">
               <a:ext uri="{FF2B5EF4-FFF2-40B4-BE49-F238E27FC236}">
-                <a16:creationId xmlns:a16="http://schemas.microsoft.com/office/drawing/2014/main" id="{3E8B7D8A-B4AC-4CEB-94C7-D4504BAA6DEA}"/>
+                <a16:creationId xmlns:a16="http://schemas.microsoft.com/office/drawing/2014/main" id="{FBF9CC36-52C0-4FAE-BF8B-F53DF4A5E6AA}"/>
               </a:ext>
             </a:extLst>
           </p:cNvPr>
@@ -15204,7 +15204,7 @@
           <p:cNvPr id="7" name="">
             <a:extLst xmlns:a="http://schemas.openxmlformats.org/drawingml/2006/main">
               <a:ext uri="{FF2B5EF4-FFF2-40B4-BE49-F238E27FC236}">
-                <a16:creationId xmlns:a16="http://schemas.microsoft.com/office/drawing/2014/main" id="{5A70F40A-BA47-4FF2-9882-4E6BAEC039B5}"/>
+                <a16:creationId xmlns:a16="http://schemas.microsoft.com/office/drawing/2014/main" id="{F03F3122-116C-45DC-8064-649E18D8626A}"/>
               </a:ext>
             </a:extLst>
           </p:cNvPr>
@@ -15268,7 +15268,7 @@
           <p:cNvPr id="8" name="">
             <a:extLst xmlns:a="http://schemas.openxmlformats.org/drawingml/2006/main">
               <a:ext uri="{FF2B5EF4-FFF2-40B4-BE49-F238E27FC236}">
-                <a16:creationId xmlns:a16="http://schemas.microsoft.com/office/drawing/2014/main" id="{1069241D-E3BF-4020-8F67-2D29BD737DA3}"/>
+                <a16:creationId xmlns:a16="http://schemas.microsoft.com/office/drawing/2014/main" id="{E4854881-FE17-49CC-8121-879A4379E540}"/>
               </a:ext>
             </a:extLst>
           </p:cNvPr>
@@ -15330,7 +15330,7 @@
     </p:spTree>
     <p:extLst>
       <p:ext uri="{BB962C8B-B14F-4D97-AF65-F5344CB8AC3E}">
-        <p14:creationId xmlns:p14="http://schemas.microsoft.com/office/powerpoint/2010/main" val="1644359960"/>
+        <p14:creationId xmlns:p14="http://schemas.microsoft.com/office/powerpoint/2010/main" val="836428822"/>
       </p:ext>
     </p:extLst>
   </p:cSld>

</xml_diff>